<commit_message>
Move word clouds to visualizations folder and update welcome address
- Moved word cloud images to visualizations/ directory for better organization
- Updated PowerPoint welcome address presentation

Co-Authored-By: Claude Sonnet 4.5 <noreply@anthropic.com>
</commit_message>
<xml_diff>
--- a/DASHSys-2026-Welcome-Address.pptx
+++ b/DASHSys-2026-Welcome-Address.pptx
@@ -5,18 +5,19 @@
     <p:sldMasterId id="2147483648" r:id="rId1"/>
   </p:sldMasterIdLst>
   <p:sldIdLst>
-    <p:sldId id="256" r:id="rId7"/>
-    <p:sldId id="257" r:id="rId8"/>
-    <p:sldId id="258" r:id="rId9"/>
-    <p:sldId id="259" r:id="rId10"/>
-    <p:sldId id="260" r:id="rId11"/>
-    <p:sldId id="261" r:id="rId12"/>
-    <p:sldId id="262" r:id="rId13"/>
-    <p:sldId id="263" r:id="rId14"/>
-    <p:sldId id="264" r:id="rId15"/>
-    <p:sldId id="265" r:id="rId16"/>
+    <p:sldId id="266" r:id="rId2"/>
+    <p:sldId id="267" r:id="rId3"/>
+    <p:sldId id="268" r:id="rId4"/>
+    <p:sldId id="258" r:id="rId5"/>
+    <p:sldId id="259" r:id="rId6"/>
+    <p:sldId id="260" r:id="rId7"/>
+    <p:sldId id="261" r:id="rId8"/>
+    <p:sldId id="262" r:id="rId9"/>
+    <p:sldId id="263" r:id="rId10"/>
+    <p:sldId id="264" r:id="rId11"/>
+    <p:sldId id="265" r:id="rId12"/>
   </p:sldIdLst>
-  <p:sldSz cx="12191695" cy="6858000" type="screen4x3"/>
+  <p:sldSz cx="12192000" cy="6858000"/>
   <p:notesSz cx="6858000" cy="9144000"/>
   <p:defaultTextStyle>
     <a:defPPr>
@@ -113,6 +114,22 @@
       </a:defRPr>
     </a:lvl9pPr>
   </p:defaultTextStyle>
+  <p:extLst>
+    <p:ext uri="{EFAFB233-063F-42B5-8137-9DF3F51BA10A}">
+      <p15:sldGuideLst xmlns:p15="http://schemas.microsoft.com/office/powerpoint/2012/main">
+        <p15:guide id="1" orient="horz" pos="2160">
+          <p15:clr>
+            <a:srgbClr val="A4A3A4"/>
+          </p15:clr>
+        </p15:guide>
+        <p15:guide id="2" pos="2880">
+          <p15:clr>
+            <a:srgbClr val="A4A3A4"/>
+          </p15:clr>
+        </p15:guide>
+      </p15:sldGuideLst>
+    </p:ext>
+  </p:extLst>
 </p:presentation>
 </file>
 
@@ -154,10 +171,9 @@
           <a:lstStyle/>
           <a:p>
             <a:r>
-              <a:rPr lang="en-US" smtClean="0"/>
+              <a:rPr lang="en-US"/>
               <a:t>Click to edit Master title style</a:t>
             </a:r>
-            <a:endParaRPr lang="en-US"/>
           </a:p>
         </p:txBody>
       </p:sp>
@@ -273,10 +289,9 @@
           </a:lstStyle>
           <a:p>
             <a:r>
-              <a:rPr lang="en-US" smtClean="0"/>
+              <a:rPr lang="en-US"/>
               <a:t>Click to edit Master subtitle style</a:t>
             </a:r>
-            <a:endParaRPr lang="en-US"/>
           </a:p>
         </p:txBody>
       </p:sp>
@@ -297,7 +312,7 @@
           <a:p>
             <a:fld id="{5BCAD085-E8A6-8845-BD4E-CB4CCA059FC4}" type="datetimeFigureOut">
               <a:rPr lang="en-US" smtClean="0"/>
-              <a:t>1/27/13</a:t>
+              <a:t>9/3/26</a:t>
             </a:fld>
             <a:endParaRPr lang="en-US"/>
           </a:p>
@@ -391,10 +406,9 @@
           <a:lstStyle/>
           <a:p>
             <a:r>
-              <a:rPr lang="en-US" smtClean="0"/>
+              <a:rPr lang="en-US"/>
               <a:t>Click to edit Master title style</a:t>
             </a:r>
-            <a:endParaRPr lang="en-US"/>
           </a:p>
         </p:txBody>
       </p:sp>
@@ -415,38 +429,37 @@
           <a:p>
             <a:pPr lvl="0"/>
             <a:r>
-              <a:rPr lang="en-US" smtClean="0"/>
+              <a:rPr lang="en-US"/>
               <a:t>Click to edit Master text styles</a:t>
             </a:r>
           </a:p>
           <a:p>
             <a:pPr lvl="1"/>
             <a:r>
-              <a:rPr lang="en-US" smtClean="0"/>
+              <a:rPr lang="en-US"/>
               <a:t>Second level</a:t>
             </a:r>
           </a:p>
           <a:p>
             <a:pPr lvl="2"/>
             <a:r>
-              <a:rPr lang="en-US" smtClean="0"/>
+              <a:rPr lang="en-US"/>
               <a:t>Third level</a:t>
             </a:r>
           </a:p>
           <a:p>
             <a:pPr lvl="3"/>
             <a:r>
-              <a:rPr lang="en-US" smtClean="0"/>
+              <a:rPr lang="en-US"/>
               <a:t>Fourth level</a:t>
             </a:r>
           </a:p>
           <a:p>
             <a:pPr lvl="4"/>
             <a:r>
-              <a:rPr lang="en-US" smtClean="0"/>
+              <a:rPr lang="en-US"/>
               <a:t>Fifth level</a:t>
             </a:r>
-            <a:endParaRPr lang="en-US"/>
           </a:p>
         </p:txBody>
       </p:sp>
@@ -467,7 +480,7 @@
           <a:p>
             <a:fld id="{5BCAD085-E8A6-8845-BD4E-CB4CCA059FC4}" type="datetimeFigureOut">
               <a:rPr lang="en-US" smtClean="0"/>
-              <a:t>1/27/13</a:t>
+              <a:t>9/3/26</a:t>
             </a:fld>
             <a:endParaRPr lang="en-US"/>
           </a:p>
@@ -566,10 +579,9 @@
           <a:lstStyle/>
           <a:p>
             <a:r>
-              <a:rPr lang="en-US" smtClean="0"/>
+              <a:rPr lang="en-US"/>
               <a:t>Click to edit Master title style</a:t>
             </a:r>
-            <a:endParaRPr lang="en-US"/>
           </a:p>
         </p:txBody>
       </p:sp>
@@ -595,38 +607,37 @@
           <a:p>
             <a:pPr lvl="0"/>
             <a:r>
-              <a:rPr lang="en-US" smtClean="0"/>
+              <a:rPr lang="en-US"/>
               <a:t>Click to edit Master text styles</a:t>
             </a:r>
           </a:p>
           <a:p>
             <a:pPr lvl="1"/>
             <a:r>
-              <a:rPr lang="en-US" smtClean="0"/>
+              <a:rPr lang="en-US"/>
               <a:t>Second level</a:t>
             </a:r>
           </a:p>
           <a:p>
             <a:pPr lvl="2"/>
             <a:r>
-              <a:rPr lang="en-US" smtClean="0"/>
+              <a:rPr lang="en-US"/>
               <a:t>Third level</a:t>
             </a:r>
           </a:p>
           <a:p>
             <a:pPr lvl="3"/>
             <a:r>
-              <a:rPr lang="en-US" smtClean="0"/>
+              <a:rPr lang="en-US"/>
               <a:t>Fourth level</a:t>
             </a:r>
           </a:p>
           <a:p>
             <a:pPr lvl="4"/>
             <a:r>
-              <a:rPr lang="en-US" smtClean="0"/>
+              <a:rPr lang="en-US"/>
               <a:t>Fifth level</a:t>
             </a:r>
-            <a:endParaRPr lang="en-US"/>
           </a:p>
         </p:txBody>
       </p:sp>
@@ -647,7 +658,7 @@
           <a:p>
             <a:fld id="{5BCAD085-E8A6-8845-BD4E-CB4CCA059FC4}" type="datetimeFigureOut">
               <a:rPr lang="en-US" smtClean="0"/>
-              <a:t>1/27/13</a:t>
+              <a:t>9/3/26</a:t>
             </a:fld>
             <a:endParaRPr lang="en-US"/>
           </a:p>
@@ -741,10 +752,9 @@
           <a:lstStyle/>
           <a:p>
             <a:r>
-              <a:rPr lang="en-US" smtClean="0"/>
+              <a:rPr lang="en-US"/>
               <a:t>Click to edit Master title style</a:t>
             </a:r>
-            <a:endParaRPr lang="en-US"/>
           </a:p>
         </p:txBody>
       </p:sp>
@@ -765,38 +775,37 @@
           <a:p>
             <a:pPr lvl="0"/>
             <a:r>
-              <a:rPr lang="en-US" smtClean="0"/>
+              <a:rPr lang="en-US"/>
               <a:t>Click to edit Master text styles</a:t>
             </a:r>
           </a:p>
           <a:p>
             <a:pPr lvl="1"/>
             <a:r>
-              <a:rPr lang="en-US" smtClean="0"/>
+              <a:rPr lang="en-US"/>
               <a:t>Second level</a:t>
             </a:r>
           </a:p>
           <a:p>
             <a:pPr lvl="2"/>
             <a:r>
-              <a:rPr lang="en-US" smtClean="0"/>
+              <a:rPr lang="en-US"/>
               <a:t>Third level</a:t>
             </a:r>
           </a:p>
           <a:p>
             <a:pPr lvl="3"/>
             <a:r>
-              <a:rPr lang="en-US" smtClean="0"/>
+              <a:rPr lang="en-US"/>
               <a:t>Fourth level</a:t>
             </a:r>
           </a:p>
           <a:p>
             <a:pPr lvl="4"/>
             <a:r>
-              <a:rPr lang="en-US" smtClean="0"/>
+              <a:rPr lang="en-US"/>
               <a:t>Fifth level</a:t>
             </a:r>
-            <a:endParaRPr lang="en-US"/>
           </a:p>
         </p:txBody>
       </p:sp>
@@ -817,7 +826,7 @@
           <a:p>
             <a:fld id="{5BCAD085-E8A6-8845-BD4E-CB4CCA059FC4}" type="datetimeFigureOut">
               <a:rPr lang="en-US" smtClean="0"/>
-              <a:t>1/27/13</a:t>
+              <a:t>9/3/26</a:t>
             </a:fld>
             <a:endParaRPr lang="en-US"/>
           </a:p>
@@ -920,10 +929,9 @@
           </a:lstStyle>
           <a:p>
             <a:r>
-              <a:rPr lang="en-US" smtClean="0"/>
+              <a:rPr lang="en-US"/>
               <a:t>Click to edit Master title style</a:t>
             </a:r>
-            <a:endParaRPr lang="en-US"/>
           </a:p>
         </p:txBody>
       </p:sp>
@@ -1040,7 +1048,7 @@
           <a:p>
             <a:pPr lvl="0"/>
             <a:r>
-              <a:rPr lang="en-US" smtClean="0"/>
+              <a:rPr lang="en-US"/>
               <a:t>Click to edit Master text styles</a:t>
             </a:r>
           </a:p>
@@ -1063,7 +1071,7 @@
           <a:p>
             <a:fld id="{5BCAD085-E8A6-8845-BD4E-CB4CCA059FC4}" type="datetimeFigureOut">
               <a:rPr lang="en-US" smtClean="0"/>
-              <a:t>1/27/13</a:t>
+              <a:t>9/3/26</a:t>
             </a:fld>
             <a:endParaRPr lang="en-US"/>
           </a:p>
@@ -1157,10 +1165,9 @@
           <a:lstStyle/>
           <a:p>
             <a:r>
-              <a:rPr lang="en-US" smtClean="0"/>
+              <a:rPr lang="en-US"/>
               <a:t>Click to edit Master title style</a:t>
             </a:r>
-            <a:endParaRPr lang="en-US"/>
           </a:p>
         </p:txBody>
       </p:sp>
@@ -1214,38 +1221,37 @@
           <a:p>
             <a:pPr lvl="0"/>
             <a:r>
-              <a:rPr lang="en-US" smtClean="0"/>
+              <a:rPr lang="en-US"/>
               <a:t>Click to edit Master text styles</a:t>
             </a:r>
           </a:p>
           <a:p>
             <a:pPr lvl="1"/>
             <a:r>
-              <a:rPr lang="en-US" smtClean="0"/>
+              <a:rPr lang="en-US"/>
               <a:t>Second level</a:t>
             </a:r>
           </a:p>
           <a:p>
             <a:pPr lvl="2"/>
             <a:r>
-              <a:rPr lang="en-US" smtClean="0"/>
+              <a:rPr lang="en-US"/>
               <a:t>Third level</a:t>
             </a:r>
           </a:p>
           <a:p>
             <a:pPr lvl="3"/>
             <a:r>
-              <a:rPr lang="en-US" smtClean="0"/>
+              <a:rPr lang="en-US"/>
               <a:t>Fourth level</a:t>
             </a:r>
           </a:p>
           <a:p>
             <a:pPr lvl="4"/>
             <a:r>
-              <a:rPr lang="en-US" smtClean="0"/>
+              <a:rPr lang="en-US"/>
               <a:t>Fifth level</a:t>
             </a:r>
-            <a:endParaRPr lang="en-US"/>
           </a:p>
         </p:txBody>
       </p:sp>
@@ -1299,38 +1305,37 @@
           <a:p>
             <a:pPr lvl="0"/>
             <a:r>
-              <a:rPr lang="en-US" smtClean="0"/>
+              <a:rPr lang="en-US"/>
               <a:t>Click to edit Master text styles</a:t>
             </a:r>
           </a:p>
           <a:p>
             <a:pPr lvl="1"/>
             <a:r>
-              <a:rPr lang="en-US" smtClean="0"/>
+              <a:rPr lang="en-US"/>
               <a:t>Second level</a:t>
             </a:r>
           </a:p>
           <a:p>
             <a:pPr lvl="2"/>
             <a:r>
-              <a:rPr lang="en-US" smtClean="0"/>
+              <a:rPr lang="en-US"/>
               <a:t>Third level</a:t>
             </a:r>
           </a:p>
           <a:p>
             <a:pPr lvl="3"/>
             <a:r>
-              <a:rPr lang="en-US" smtClean="0"/>
+              <a:rPr lang="en-US"/>
               <a:t>Fourth level</a:t>
             </a:r>
           </a:p>
           <a:p>
             <a:pPr lvl="4"/>
             <a:r>
-              <a:rPr lang="en-US" smtClean="0"/>
+              <a:rPr lang="en-US"/>
               <a:t>Fifth level</a:t>
             </a:r>
-            <a:endParaRPr lang="en-US"/>
           </a:p>
         </p:txBody>
       </p:sp>
@@ -1351,7 +1356,7 @@
           <a:p>
             <a:fld id="{5BCAD085-E8A6-8845-BD4E-CB4CCA059FC4}" type="datetimeFigureOut">
               <a:rPr lang="en-US" smtClean="0"/>
-              <a:t>1/27/13</a:t>
+              <a:t>9/3/26</a:t>
             </a:fld>
             <a:endParaRPr lang="en-US"/>
           </a:p>
@@ -1449,10 +1454,9 @@
           </a:lstStyle>
           <a:p>
             <a:r>
-              <a:rPr lang="en-US" smtClean="0"/>
+              <a:rPr lang="en-US"/>
               <a:t>Click to edit Master title style</a:t>
             </a:r>
-            <a:endParaRPr lang="en-US"/>
           </a:p>
         </p:txBody>
       </p:sp>
@@ -1515,7 +1519,7 @@
           <a:p>
             <a:pPr lvl="0"/>
             <a:r>
-              <a:rPr lang="en-US" smtClean="0"/>
+              <a:rPr lang="en-US"/>
               <a:t>Click to edit Master text styles</a:t>
             </a:r>
           </a:p>
@@ -1571,38 +1575,37 @@
           <a:p>
             <a:pPr lvl="0"/>
             <a:r>
-              <a:rPr lang="en-US" smtClean="0"/>
+              <a:rPr lang="en-US"/>
               <a:t>Click to edit Master text styles</a:t>
             </a:r>
           </a:p>
           <a:p>
             <a:pPr lvl="1"/>
             <a:r>
-              <a:rPr lang="en-US" smtClean="0"/>
+              <a:rPr lang="en-US"/>
               <a:t>Second level</a:t>
             </a:r>
           </a:p>
           <a:p>
             <a:pPr lvl="2"/>
             <a:r>
-              <a:rPr lang="en-US" smtClean="0"/>
+              <a:rPr lang="en-US"/>
               <a:t>Third level</a:t>
             </a:r>
           </a:p>
           <a:p>
             <a:pPr lvl="3"/>
             <a:r>
-              <a:rPr lang="en-US" smtClean="0"/>
+              <a:rPr lang="en-US"/>
               <a:t>Fourth level</a:t>
             </a:r>
           </a:p>
           <a:p>
             <a:pPr lvl="4"/>
             <a:r>
-              <a:rPr lang="en-US" smtClean="0"/>
+              <a:rPr lang="en-US"/>
               <a:t>Fifth level</a:t>
             </a:r>
-            <a:endParaRPr lang="en-US"/>
           </a:p>
         </p:txBody>
       </p:sp>
@@ -1665,7 +1668,7 @@
           <a:p>
             <a:pPr lvl="0"/>
             <a:r>
-              <a:rPr lang="en-US" smtClean="0"/>
+              <a:rPr lang="en-US"/>
               <a:t>Click to edit Master text styles</a:t>
             </a:r>
           </a:p>
@@ -1721,38 +1724,37 @@
           <a:p>
             <a:pPr lvl="0"/>
             <a:r>
-              <a:rPr lang="en-US" smtClean="0"/>
+              <a:rPr lang="en-US"/>
               <a:t>Click to edit Master text styles</a:t>
             </a:r>
           </a:p>
           <a:p>
             <a:pPr lvl="1"/>
             <a:r>
-              <a:rPr lang="en-US" smtClean="0"/>
+              <a:rPr lang="en-US"/>
               <a:t>Second level</a:t>
             </a:r>
           </a:p>
           <a:p>
             <a:pPr lvl="2"/>
             <a:r>
-              <a:rPr lang="en-US" smtClean="0"/>
+              <a:rPr lang="en-US"/>
               <a:t>Third level</a:t>
             </a:r>
           </a:p>
           <a:p>
             <a:pPr lvl="3"/>
             <a:r>
-              <a:rPr lang="en-US" smtClean="0"/>
+              <a:rPr lang="en-US"/>
               <a:t>Fourth level</a:t>
             </a:r>
           </a:p>
           <a:p>
             <a:pPr lvl="4"/>
             <a:r>
-              <a:rPr lang="en-US" smtClean="0"/>
+              <a:rPr lang="en-US"/>
               <a:t>Fifth level</a:t>
             </a:r>
-            <a:endParaRPr lang="en-US"/>
           </a:p>
         </p:txBody>
       </p:sp>
@@ -1773,7 +1775,7 @@
           <a:p>
             <a:fld id="{5BCAD085-E8A6-8845-BD4E-CB4CCA059FC4}" type="datetimeFigureOut">
               <a:rPr lang="en-US" smtClean="0"/>
-              <a:t>1/27/13</a:t>
+              <a:t>9/3/26</a:t>
             </a:fld>
             <a:endParaRPr lang="en-US"/>
           </a:p>
@@ -1867,10 +1869,9 @@
           <a:lstStyle/>
           <a:p>
             <a:r>
-              <a:rPr lang="en-US" smtClean="0"/>
+              <a:rPr lang="en-US"/>
               <a:t>Click to edit Master title style</a:t>
             </a:r>
-            <a:endParaRPr lang="en-US"/>
           </a:p>
         </p:txBody>
       </p:sp>
@@ -1891,7 +1892,7 @@
           <a:p>
             <a:fld id="{5BCAD085-E8A6-8845-BD4E-CB4CCA059FC4}" type="datetimeFigureOut">
               <a:rPr lang="en-US" smtClean="0"/>
-              <a:t>1/27/13</a:t>
+              <a:t>9/3/26</a:t>
             </a:fld>
             <a:endParaRPr lang="en-US"/>
           </a:p>
@@ -1986,7 +1987,7 @@
           <a:p>
             <a:fld id="{5BCAD085-E8A6-8845-BD4E-CB4CCA059FC4}" type="datetimeFigureOut">
               <a:rPr lang="en-US" smtClean="0"/>
-              <a:t>1/27/13</a:t>
+              <a:t>9/3/26</a:t>
             </a:fld>
             <a:endParaRPr lang="en-US"/>
           </a:p>
@@ -2089,10 +2090,9 @@
           </a:lstStyle>
           <a:p>
             <a:r>
-              <a:rPr lang="en-US" smtClean="0"/>
+              <a:rPr lang="en-US"/>
               <a:t>Click to edit Master title style</a:t>
             </a:r>
-            <a:endParaRPr lang="en-US"/>
           </a:p>
         </p:txBody>
       </p:sp>
@@ -2146,38 +2146,37 @@
           <a:p>
             <a:pPr lvl="0"/>
             <a:r>
-              <a:rPr lang="en-US" smtClean="0"/>
+              <a:rPr lang="en-US"/>
               <a:t>Click to edit Master text styles</a:t>
             </a:r>
           </a:p>
           <a:p>
             <a:pPr lvl="1"/>
             <a:r>
-              <a:rPr lang="en-US" smtClean="0"/>
+              <a:rPr lang="en-US"/>
               <a:t>Second level</a:t>
             </a:r>
           </a:p>
           <a:p>
             <a:pPr lvl="2"/>
             <a:r>
-              <a:rPr lang="en-US" smtClean="0"/>
+              <a:rPr lang="en-US"/>
               <a:t>Third level</a:t>
             </a:r>
           </a:p>
           <a:p>
             <a:pPr lvl="3"/>
             <a:r>
-              <a:rPr lang="en-US" smtClean="0"/>
+              <a:rPr lang="en-US"/>
               <a:t>Fourth level</a:t>
             </a:r>
           </a:p>
           <a:p>
             <a:pPr lvl="4"/>
             <a:r>
-              <a:rPr lang="en-US" smtClean="0"/>
+              <a:rPr lang="en-US"/>
               <a:t>Fifth level</a:t>
             </a:r>
-            <a:endParaRPr lang="en-US"/>
           </a:p>
         </p:txBody>
       </p:sp>
@@ -2240,7 +2239,7 @@
           <a:p>
             <a:pPr lvl="0"/>
             <a:r>
-              <a:rPr lang="en-US" smtClean="0"/>
+              <a:rPr lang="en-US"/>
               <a:t>Click to edit Master text styles</a:t>
             </a:r>
           </a:p>
@@ -2263,7 +2262,7 @@
           <a:p>
             <a:fld id="{5BCAD085-E8A6-8845-BD4E-CB4CCA059FC4}" type="datetimeFigureOut">
               <a:rPr lang="en-US" smtClean="0"/>
-              <a:t>1/27/13</a:t>
+              <a:t>9/3/26</a:t>
             </a:fld>
             <a:endParaRPr lang="en-US"/>
           </a:p>
@@ -2366,10 +2365,9 @@
           </a:lstStyle>
           <a:p>
             <a:r>
-              <a:rPr lang="en-US" smtClean="0"/>
+              <a:rPr lang="en-US"/>
               <a:t>Click to edit Master title style</a:t>
             </a:r>
-            <a:endParaRPr lang="en-US"/>
           </a:p>
         </p:txBody>
       </p:sp>
@@ -2493,7 +2491,7 @@
           <a:p>
             <a:pPr lvl="0"/>
             <a:r>
-              <a:rPr lang="en-US" smtClean="0"/>
+              <a:rPr lang="en-US"/>
               <a:t>Click to edit Master text styles</a:t>
             </a:r>
           </a:p>
@@ -2516,7 +2514,7 @@
           <a:p>
             <a:fld id="{5BCAD085-E8A6-8845-BD4E-CB4CCA059FC4}" type="datetimeFigureOut">
               <a:rPr lang="en-US" smtClean="0"/>
-              <a:t>1/27/13</a:t>
+              <a:t>9/3/26</a:t>
             </a:fld>
             <a:endParaRPr lang="en-US"/>
           </a:p>
@@ -2625,10 +2623,9 @@
           <a:lstStyle/>
           <a:p>
             <a:r>
-              <a:rPr lang="en-US" smtClean="0"/>
+              <a:rPr lang="en-US"/>
               <a:t>Click to edit Master title style</a:t>
             </a:r>
-            <a:endParaRPr lang="en-US"/>
           </a:p>
         </p:txBody>
       </p:sp>
@@ -2659,38 +2656,37 @@
           <a:p>
             <a:pPr lvl="0"/>
             <a:r>
-              <a:rPr lang="en-US" smtClean="0"/>
+              <a:rPr lang="en-US"/>
               <a:t>Click to edit Master text styles</a:t>
             </a:r>
           </a:p>
           <a:p>
             <a:pPr lvl="1"/>
             <a:r>
-              <a:rPr lang="en-US" smtClean="0"/>
+              <a:rPr lang="en-US"/>
               <a:t>Second level</a:t>
             </a:r>
           </a:p>
           <a:p>
             <a:pPr lvl="2"/>
             <a:r>
-              <a:rPr lang="en-US" smtClean="0"/>
+              <a:rPr lang="en-US"/>
               <a:t>Third level</a:t>
             </a:r>
           </a:p>
           <a:p>
             <a:pPr lvl="3"/>
             <a:r>
-              <a:rPr lang="en-US" smtClean="0"/>
+              <a:rPr lang="en-US"/>
               <a:t>Fourth level</a:t>
             </a:r>
           </a:p>
           <a:p>
             <a:pPr lvl="4"/>
             <a:r>
-              <a:rPr lang="en-US" smtClean="0"/>
+              <a:rPr lang="en-US"/>
               <a:t>Fifth level</a:t>
             </a:r>
-            <a:endParaRPr lang="en-US"/>
           </a:p>
         </p:txBody>
       </p:sp>
@@ -2729,7 +2725,7 @@
           <a:p>
             <a:fld id="{5BCAD085-E8A6-8845-BD4E-CB4CCA059FC4}" type="datetimeFigureOut">
               <a:rPr lang="en-US" smtClean="0"/>
-              <a:t>1/27/13</a:t>
+              <a:t>9/3/26</a:t>
             </a:fld>
             <a:endParaRPr lang="en-US"/>
           </a:p>
@@ -3088,7 +3084,636 @@
 </file>
 
 <file path=ppt/slides/slide1.xml><?xml version="1.0" encoding="utf-8"?>
-<p:sld xmlns:a="http://schemas.openxmlformats.org/drawingml/2006/main" xmlns:p="http://schemas.openxmlformats.org/presentationml/2006/main" xmlns:r="http://schemas.openxmlformats.org/officeDocument/2006/relationships">
+<p:sld xmlns:a="http://schemas.openxmlformats.org/drawingml/2006/main" xmlns:r="http://schemas.openxmlformats.org/officeDocument/2006/relationships" xmlns:p="http://schemas.openxmlformats.org/presentationml/2006/main">
+  <p:cSld>
+    <p:bg>
+      <p:bgPr>
+        <a:solidFill>
+          <a:schemeClr val="bg1"/>
+        </a:solidFill>
+        <a:effectLst/>
+      </p:bgPr>
+    </p:bg>
+    <p:spTree>
+      <p:nvGrpSpPr>
+        <p:cNvPr id="1" name=""/>
+        <p:cNvGrpSpPr/>
+        <p:nvPr/>
+      </p:nvGrpSpPr>
+      <p:grpSpPr>
+        <a:xfrm>
+          <a:off x="0" y="0"/>
+          <a:ext cx="0" cy="0"/>
+          <a:chOff x="0" y="0"/>
+          <a:chExt cx="0" cy="0"/>
+        </a:xfrm>
+      </p:grpSpPr>
+      <p:sp useBgFill="1">
+        <p:nvSpPr>
+          <p:cNvPr id="8" name="Rectangle 7">
+            <a:extLst>
+              <a:ext uri="{FF2B5EF4-FFF2-40B4-BE49-F238E27FC236}">
+                <a16:creationId xmlns:a16="http://schemas.microsoft.com/office/drawing/2014/main" id="{AB8C311F-7253-4AED-9701-7FC0708C41C7}"/>
+              </a:ext>
+              <a:ext uri="{C183D7F6-B498-43B3-948B-1728B52AA6E4}">
+                <adec:decorative xmlns:adec="http://schemas.microsoft.com/office/drawing/2017/decorative" val="1"/>
+              </a:ext>
+            </a:extLst>
+          </p:cNvPr>
+          <p:cNvSpPr>
+            <a:spLocks noGrp="1" noRot="1" noChangeAspect="1" noMove="1" noResize="1" noEditPoints="1" noAdjustHandles="1" noChangeArrowheads="1" noChangeShapeType="1" noTextEdit="1"/>
+          </p:cNvSpPr>
+          <p:nvPr>
+            <p:extLst>
+              <p:ext uri="{386F3935-93C4-4BCD-93E2-E3B085C9AB24}">
+                <p16:designElem xmlns:p16="http://schemas.microsoft.com/office/powerpoint/2015/main" val="1"/>
+              </p:ext>
+            </p:extLst>
+          </p:nvPr>
+        </p:nvSpPr>
+        <p:spPr>
+          <a:xfrm>
+            <a:off x="0" y="0"/>
+            <a:ext cx="12192000" cy="6858000"/>
+          </a:xfrm>
+          <a:prstGeom prst="rect">
+            <a:avLst/>
+          </a:prstGeom>
+          <a:ln w="12700" cap="flat" cmpd="sng" algn="ctr">
+            <a:noFill/>
+            <a:prstDash val="solid"/>
+            <a:miter lim="800000"/>
+          </a:ln>
+          <a:effectLst/>
+          <a:extLst>
+            <a:ext uri="{91240B29-F687-4F45-9708-019B960494DF}">
+              <a14:hiddenLine xmlns:a14="http://schemas.microsoft.com/office/drawing/2010/main" w="12700" cap="flat" cmpd="sng" algn="ctr">
+                <a:solidFill>
+                  <a:schemeClr val="accent1">
+                    <a:shade val="50000"/>
+                  </a:schemeClr>
+                </a:solidFill>
+                <a:prstDash val="solid"/>
+                <a:miter lim="800000"/>
+              </a14:hiddenLine>
+            </a:ext>
+          </a:extLst>
+        </p:spPr>
+        <p:style>
+          <a:lnRef idx="2">
+            <a:schemeClr val="accent1">
+              <a:shade val="50000"/>
+            </a:schemeClr>
+          </a:lnRef>
+          <a:fillRef idx="1">
+            <a:schemeClr val="accent1"/>
+          </a:fillRef>
+          <a:effectRef idx="0">
+            <a:schemeClr val="accent1"/>
+          </a:effectRef>
+          <a:fontRef idx="minor">
+            <a:schemeClr val="lt1"/>
+          </a:fontRef>
+        </p:style>
+        <p:txBody>
+          <a:bodyPr rtlCol="0" anchor="ctr"/>
+          <a:lstStyle/>
+          <a:p>
+            <a:pPr algn="ctr"/>
+            <a:endParaRPr lang="en-US"/>
+          </a:p>
+        </p:txBody>
+      </p:sp>
+      <p:sp>
+        <p:nvSpPr>
+          <p:cNvPr id="10" name="Rectangle 9">
+            <a:extLst>
+              <a:ext uri="{FF2B5EF4-FFF2-40B4-BE49-F238E27FC236}">
+                <a16:creationId xmlns:a16="http://schemas.microsoft.com/office/drawing/2014/main" id="{E2384209-CB15-4CDF-9D31-C44FD9A3F20D}"/>
+              </a:ext>
+              <a:ext uri="{C183D7F6-B498-43B3-948B-1728B52AA6E4}">
+                <adec:decorative xmlns:adec="http://schemas.microsoft.com/office/drawing/2017/decorative" val="1"/>
+              </a:ext>
+            </a:extLst>
+          </p:cNvPr>
+          <p:cNvSpPr>
+            <a:spLocks noGrp="1" noRot="1" noChangeAspect="1" noMove="1" noResize="1" noEditPoints="1" noAdjustHandles="1" noChangeArrowheads="1" noChangeShapeType="1" noTextEdit="1"/>
+          </p:cNvSpPr>
+          <p:nvPr>
+            <p:extLst>
+              <p:ext uri="{386F3935-93C4-4BCD-93E2-E3B085C9AB24}">
+                <p16:designElem xmlns:p16="http://schemas.microsoft.com/office/powerpoint/2015/main" val="1"/>
+              </p:ext>
+            </p:extLst>
+          </p:nvPr>
+        </p:nvSpPr>
+        <p:spPr>
+          <a:xfrm rot="16200000" flipH="1">
+            <a:off x="2666617" y="-2666188"/>
+            <a:ext cx="6858000" cy="12191233"/>
+          </a:xfrm>
+          <a:prstGeom prst="rect">
+            <a:avLst/>
+          </a:prstGeom>
+          <a:gradFill>
+            <a:gsLst>
+              <a:gs pos="8000">
+                <a:schemeClr val="accent1"/>
+              </a:gs>
+              <a:gs pos="100000">
+                <a:schemeClr val="accent1">
+                  <a:lumMod val="50000"/>
+                </a:schemeClr>
+              </a:gs>
+            </a:gsLst>
+            <a:lin ang="12000000" scaled="0"/>
+          </a:gradFill>
+          <a:ln>
+            <a:noFill/>
+          </a:ln>
+        </p:spPr>
+        <p:style>
+          <a:lnRef idx="2">
+            <a:schemeClr val="accent1">
+              <a:shade val="50000"/>
+            </a:schemeClr>
+          </a:lnRef>
+          <a:fillRef idx="1">
+            <a:schemeClr val="accent1"/>
+          </a:fillRef>
+          <a:effectRef idx="0">
+            <a:schemeClr val="accent1"/>
+          </a:effectRef>
+          <a:fontRef idx="minor">
+            <a:schemeClr val="lt1"/>
+          </a:fontRef>
+        </p:style>
+        <p:txBody>
+          <a:bodyPr rtlCol="0" anchor="ctr"/>
+          <a:lstStyle/>
+          <a:p>
+            <a:pPr algn="ctr"/>
+            <a:endParaRPr lang="en-US"/>
+          </a:p>
+        </p:txBody>
+      </p:sp>
+      <p:sp>
+        <p:nvSpPr>
+          <p:cNvPr id="12" name="Rectangle 11">
+            <a:extLst>
+              <a:ext uri="{FF2B5EF4-FFF2-40B4-BE49-F238E27FC236}">
+                <a16:creationId xmlns:a16="http://schemas.microsoft.com/office/drawing/2014/main" id="{2633B3B5-CC90-43F0-8714-D31D1F3F0209}"/>
+              </a:ext>
+              <a:ext uri="{C183D7F6-B498-43B3-948B-1728B52AA6E4}">
+                <adec:decorative xmlns:adec="http://schemas.microsoft.com/office/drawing/2017/decorative" val="1"/>
+              </a:ext>
+            </a:extLst>
+          </p:cNvPr>
+          <p:cNvSpPr>
+            <a:spLocks noGrp="1" noRot="1" noChangeAspect="1" noMove="1" noResize="1" noEditPoints="1" noAdjustHandles="1" noChangeArrowheads="1" noChangeShapeType="1" noTextEdit="1"/>
+          </p:cNvSpPr>
+          <p:nvPr>
+            <p:extLst>
+              <p:ext uri="{386F3935-93C4-4BCD-93E2-E3B085C9AB24}">
+                <p16:designElem xmlns:p16="http://schemas.microsoft.com/office/powerpoint/2015/main" val="1"/>
+              </p:ext>
+            </p:extLst>
+          </p:nvPr>
+        </p:nvSpPr>
+        <p:spPr>
+          <a:xfrm rot="10800000" flipH="1">
+            <a:off x="-2311" y="0"/>
+            <a:ext cx="9070846" cy="6857572"/>
+          </a:xfrm>
+          <a:prstGeom prst="rect">
+            <a:avLst/>
+          </a:prstGeom>
+          <a:gradFill>
+            <a:gsLst>
+              <a:gs pos="8000">
+                <a:srgbClr val="000000">
+                  <a:alpha val="52000"/>
+                </a:srgbClr>
+              </a:gs>
+              <a:gs pos="100000">
+                <a:schemeClr val="accent1"/>
+              </a:gs>
+            </a:gsLst>
+            <a:lin ang="4800000" scaled="0"/>
+          </a:gradFill>
+          <a:ln>
+            <a:noFill/>
+          </a:ln>
+        </p:spPr>
+        <p:style>
+          <a:lnRef idx="2">
+            <a:schemeClr val="accent1">
+              <a:shade val="50000"/>
+            </a:schemeClr>
+          </a:lnRef>
+          <a:fillRef idx="1">
+            <a:schemeClr val="accent1"/>
+          </a:fillRef>
+          <a:effectRef idx="0">
+            <a:schemeClr val="accent1"/>
+          </a:effectRef>
+          <a:fontRef idx="minor">
+            <a:schemeClr val="lt1"/>
+          </a:fontRef>
+        </p:style>
+        <p:txBody>
+          <a:bodyPr rtlCol="0" anchor="ctr"/>
+          <a:lstStyle/>
+          <a:p>
+            <a:pPr algn="ctr"/>
+            <a:endParaRPr lang="en-US"/>
+          </a:p>
+        </p:txBody>
+      </p:sp>
+      <p:sp>
+        <p:nvSpPr>
+          <p:cNvPr id="14" name="Rectangle 13">
+            <a:extLst>
+              <a:ext uri="{FF2B5EF4-FFF2-40B4-BE49-F238E27FC236}">
+                <a16:creationId xmlns:a16="http://schemas.microsoft.com/office/drawing/2014/main" id="{A8D57A06-A426-446D-B02C-A2DC6B62E45E}"/>
+              </a:ext>
+              <a:ext uri="{C183D7F6-B498-43B3-948B-1728B52AA6E4}">
+                <adec:decorative xmlns:adec="http://schemas.microsoft.com/office/drawing/2017/decorative" val="1"/>
+              </a:ext>
+            </a:extLst>
+          </p:cNvPr>
+          <p:cNvSpPr>
+            <a:spLocks noGrp="1" noRot="1" noChangeAspect="1" noMove="1" noResize="1" noEditPoints="1" noAdjustHandles="1" noChangeArrowheads="1" noChangeShapeType="1" noTextEdit="1"/>
+          </p:cNvSpPr>
+          <p:nvPr>
+            <p:extLst>
+              <p:ext uri="{386F3935-93C4-4BCD-93E2-E3B085C9AB24}">
+                <p16:designElem xmlns:p16="http://schemas.microsoft.com/office/powerpoint/2015/main" val="1"/>
+              </p:ext>
+            </p:extLst>
+          </p:nvPr>
+        </p:nvSpPr>
+        <p:spPr>
+          <a:xfrm rot="16200000" flipH="1">
+            <a:off x="3649491" y="-1685840"/>
+            <a:ext cx="4894564" cy="12193546"/>
+          </a:xfrm>
+          <a:prstGeom prst="rect">
+            <a:avLst/>
+          </a:prstGeom>
+          <a:gradFill>
+            <a:gsLst>
+              <a:gs pos="0">
+                <a:schemeClr val="accent5">
+                  <a:lumMod val="60000"/>
+                  <a:lumOff val="40000"/>
+                  <a:alpha val="0"/>
+                </a:schemeClr>
+              </a:gs>
+              <a:gs pos="100000">
+                <a:srgbClr val="000000">
+                  <a:alpha val="46000"/>
+                </a:srgbClr>
+              </a:gs>
+            </a:gsLst>
+            <a:lin ang="1200000" scaled="0"/>
+          </a:gradFill>
+          <a:ln>
+            <a:noFill/>
+          </a:ln>
+        </p:spPr>
+        <p:style>
+          <a:lnRef idx="2">
+            <a:schemeClr val="accent1">
+              <a:shade val="50000"/>
+            </a:schemeClr>
+          </a:lnRef>
+          <a:fillRef idx="1">
+            <a:schemeClr val="accent1"/>
+          </a:fillRef>
+          <a:effectRef idx="0">
+            <a:schemeClr val="accent1"/>
+          </a:effectRef>
+          <a:fontRef idx="minor">
+            <a:schemeClr val="lt1"/>
+          </a:fontRef>
+        </p:style>
+        <p:txBody>
+          <a:bodyPr rtlCol="0" anchor="ctr"/>
+          <a:lstStyle/>
+          <a:p>
+            <a:pPr algn="ctr"/>
+            <a:endParaRPr lang="en-US"/>
+          </a:p>
+        </p:txBody>
+      </p:sp>
+      <p:pic>
+        <p:nvPicPr>
+          <p:cNvPr id="3" name="Picture 2">
+            <a:extLst>
+              <a:ext uri="{FF2B5EF4-FFF2-40B4-BE49-F238E27FC236}">
+                <a16:creationId xmlns:a16="http://schemas.microsoft.com/office/drawing/2014/main" id="{3B9FF68E-AEC2-C49E-5C50-0C055675E585}"/>
+              </a:ext>
+            </a:extLst>
+          </p:cNvPr>
+          <p:cNvPicPr>
+            <a:picLocks noChangeAspect="1"/>
+          </p:cNvPicPr>
+          <p:nvPr/>
+        </p:nvPicPr>
+        <p:blipFill>
+          <a:blip r:embed="rId2"/>
+          <a:srcRect l="859" r="-1" b="-1"/>
+          <a:stretch>
+            <a:fillRect/>
+          </a:stretch>
+        </p:blipFill>
+        <p:spPr>
+          <a:xfrm>
+            <a:off x="457200" y="457200"/>
+            <a:ext cx="11277600" cy="5943600"/>
+          </a:xfrm>
+          <a:prstGeom prst="rect">
+            <a:avLst/>
+          </a:prstGeom>
+        </p:spPr>
+      </p:pic>
+    </p:spTree>
+    <p:extLst>
+      <p:ext uri="{BB962C8B-B14F-4D97-AF65-F5344CB8AC3E}">
+        <p14:creationId xmlns:p14="http://schemas.microsoft.com/office/powerpoint/2010/main" val="2940019029"/>
+      </p:ext>
+    </p:extLst>
+  </p:cSld>
+  <p:clrMapOvr>
+    <a:masterClrMapping/>
+  </p:clrMapOvr>
+</p:sld>
+</file>
+
+<file path=ppt/slides/slide10.xml><?xml version="1.0" encoding="utf-8"?>
+<p:sld xmlns:a="http://schemas.openxmlformats.org/drawingml/2006/main" xmlns:r="http://schemas.openxmlformats.org/officeDocument/2006/relationships" xmlns:p="http://schemas.openxmlformats.org/presentationml/2006/main">
+  <p:cSld>
+    <p:bg>
+      <p:bgPr>
+        <a:solidFill>
+          <a:srgbClr val="FFFFFF"/>
+        </a:solidFill>
+        <a:effectLst/>
+      </p:bgPr>
+    </p:bg>
+    <p:spTree>
+      <p:nvGrpSpPr>
+        <p:cNvPr id="1" name=""/>
+        <p:cNvGrpSpPr/>
+        <p:nvPr/>
+      </p:nvGrpSpPr>
+      <p:grpSpPr>
+        <a:xfrm>
+          <a:off x="0" y="0"/>
+          <a:ext cx="0" cy="0"/>
+          <a:chOff x="0" y="0"/>
+          <a:chExt cx="0" cy="0"/>
+        </a:xfrm>
+      </p:grpSpPr>
+      <p:sp>
+        <p:nvSpPr>
+          <p:cNvPr id="2" name="TextBox 1"/>
+          <p:cNvSpPr txBox="1"/>
+          <p:nvPr/>
+        </p:nvSpPr>
+        <p:spPr>
+          <a:xfrm>
+            <a:off x="457200" y="274320"/>
+            <a:ext cx="11277295" cy="731520"/>
+          </a:xfrm>
+          <a:prstGeom prst="rect">
+            <a:avLst/>
+          </a:prstGeom>
+          <a:noFill/>
+        </p:spPr>
+        <p:txBody>
+          <a:bodyPr wrap="none">
+            <a:spAutoFit/>
+          </a:bodyPr>
+          <a:lstStyle/>
+          <a:p>
+            <a:pPr>
+              <a:defRPr sz="4000" b="1">
+                <a:solidFill>
+                  <a:srgbClr val="1A2332"/>
+                </a:solidFill>
+              </a:defRPr>
+            </a:pPr>
+            <a:r>
+              <a:t>What Makes DASHSys Different</a:t>
+            </a:r>
+          </a:p>
+        </p:txBody>
+      </p:sp>
+      <p:sp>
+        <p:nvSpPr>
+          <p:cNvPr id="3" name="TextBox 2"/>
+          <p:cNvSpPr txBox="1"/>
+          <p:nvPr/>
+        </p:nvSpPr>
+        <p:spPr>
+          <a:xfrm>
+            <a:off x="914400" y="1371600"/>
+            <a:ext cx="10362895" cy="5029200"/>
+          </a:xfrm>
+          <a:prstGeom prst="rect">
+            <a:avLst/>
+          </a:prstGeom>
+          <a:noFill/>
+        </p:spPr>
+        <p:txBody>
+          <a:bodyPr wrap="square">
+            <a:spAutoFit/>
+          </a:bodyPr>
+          <a:lstStyle/>
+          <a:p>
+            <a:pPr>
+              <a:spcBef>
+                <a:spcPts val="1200"/>
+              </a:spcBef>
+              <a:defRPr sz="2400"/>
+            </a:pPr>
+            <a:r>
+              <a:t>1️⃣  Integration, Not Separation</a:t>
+            </a:r>
+          </a:p>
+          <a:p>
+            <a:pPr>
+              <a:spcBef>
+                <a:spcPts val="1200"/>
+              </a:spcBef>
+              <a:defRPr sz="2400"/>
+            </a:pPr>
+            <a:r>
+              <a:t>    Papers bridge data systems ↔ AI systems</a:t>
+            </a:r>
+          </a:p>
+          <a:p>
+            <a:pPr>
+              <a:spcBef>
+                <a:spcPts val="1200"/>
+              </a:spcBef>
+              <a:defRPr sz="2400"/>
+            </a:pPr>
+            <a:r>
+              <a:t>    Not 'which side wins' but 'how they work together'</a:t>
+            </a:r>
+          </a:p>
+          <a:p>
+            <a:pPr>
+              <a:spcBef>
+                <a:spcPts val="1200"/>
+              </a:spcBef>
+              <a:defRPr sz="2400"/>
+            </a:pPr>
+            <a:endParaRPr/>
+          </a:p>
+          <a:p>
+            <a:pPr>
+              <a:spcBef>
+                <a:spcPts val="1200"/>
+              </a:spcBef>
+              <a:defRPr sz="2400"/>
+            </a:pPr>
+            <a:r>
+              <a:t>2️⃣  Human-in-the-Loop is Non-Negotiable</a:t>
+            </a:r>
+          </a:p>
+          <a:p>
+            <a:pPr>
+              <a:spcBef>
+                <a:spcPts val="1200"/>
+              </a:spcBef>
+              <a:defRPr sz="2400"/>
+            </a:pPr>
+            <a:r>
+              <a:t>    58% of papers include HITL</a:t>
+            </a:r>
+          </a:p>
+          <a:p>
+            <a:pPr>
+              <a:spcBef>
+                <a:spcPts val="1200"/>
+              </a:spcBef>
+              <a:defRPr sz="2400"/>
+            </a:pPr>
+            <a:r>
+              <a:t>    Not automation vs. oversight</a:t>
+            </a:r>
+          </a:p>
+          <a:p>
+            <a:pPr>
+              <a:spcBef>
+                <a:spcPts val="1200"/>
+              </a:spcBef>
+              <a:defRPr sz="2400"/>
+            </a:pPr>
+            <a:r>
+              <a:t>    But automation WITH oversight</a:t>
+            </a:r>
+          </a:p>
+          <a:p>
+            <a:pPr>
+              <a:spcBef>
+                <a:spcPts val="1200"/>
+              </a:spcBef>
+              <a:defRPr sz="2400"/>
+            </a:pPr>
+            <a:endParaRPr/>
+          </a:p>
+          <a:p>
+            <a:pPr>
+              <a:spcBef>
+                <a:spcPts val="1200"/>
+              </a:spcBef>
+              <a:defRPr sz="2400"/>
+            </a:pPr>
+            <a:r>
+              <a:t>3️⃣  Production Reality Meets Research Vision</a:t>
+            </a:r>
+          </a:p>
+          <a:p>
+            <a:pPr>
+              <a:spcBef>
+                <a:spcPts val="1200"/>
+              </a:spcBef>
+              <a:defRPr sz="2400"/>
+            </a:pPr>
+            <a:r>
+              <a:t>    Industry speakers + academic depth</a:t>
+            </a:r>
+          </a:p>
+          <a:p>
+            <a:pPr>
+              <a:spcBef>
+                <a:spcPts val="1200"/>
+              </a:spcBef>
+              <a:defRPr sz="2400"/>
+            </a:pPr>
+            <a:r>
+              <a:t>    Systems track tests ideas on real data</a:t>
+            </a:r>
+          </a:p>
+          <a:p>
+            <a:pPr>
+              <a:spcBef>
+                <a:spcPts val="1200"/>
+              </a:spcBef>
+              <a:defRPr sz="2400"/>
+            </a:pPr>
+            <a:r>
+              <a:t>    Gap analysis → research agenda</a:t>
+            </a:r>
+          </a:p>
+          <a:p>
+            <a:pPr>
+              <a:spcBef>
+                <a:spcPts val="1200"/>
+              </a:spcBef>
+              <a:defRPr sz="2400"/>
+            </a:pPr>
+            <a:endParaRPr/>
+          </a:p>
+          <a:p>
+            <a:pPr>
+              <a:spcBef>
+                <a:spcPts val="1200"/>
+              </a:spcBef>
+              <a:defRPr sz="2400"/>
+            </a:pPr>
+            <a:r>
+              <a:t>🎯 We're not just publishing papers.</a:t>
+            </a:r>
+          </a:p>
+          <a:p>
+            <a:pPr>
+              <a:spcBef>
+                <a:spcPts val="1200"/>
+              </a:spcBef>
+              <a:defRPr sz="2400"/>
+            </a:pPr>
+            <a:r>
+              <a:t>   We're defining how data systems evolve for an agentic era.</a:t>
+            </a:r>
+          </a:p>
+        </p:txBody>
+      </p:sp>
+    </p:spTree>
+  </p:cSld>
+  <p:clrMapOvr>
+    <a:masterClrMapping/>
+  </p:clrMapOvr>
+</p:sld>
+</file>
+
+<file path=ppt/slides/slide11.xml><?xml version="1.0" encoding="utf-8"?>
+<p:sld xmlns:a="http://schemas.openxmlformats.org/drawingml/2006/main" xmlns:r="http://schemas.openxmlformats.org/officeDocument/2006/relationships" xmlns:p="http://schemas.openxmlformats.org/presentationml/2006/main">
   <p:cSld>
     <p:bg>
       <p:bgPr>
@@ -3104,7 +3729,14 @@
         <p:cNvGrpSpPr/>
         <p:nvPr/>
       </p:nvGrpSpPr>
-      <p:grpSpPr/>
+      <p:grpSpPr>
+        <a:xfrm>
+          <a:off x="0" y="0"/>
+          <a:ext cx="0" cy="0"/>
+          <a:chOff x="0" y="0"/>
+          <a:chExt cx="0" cy="0"/>
+        </a:xfrm>
+      </p:grpSpPr>
       <p:sp>
         <p:nvSpPr>
           <p:cNvPr id="2" name="TextBox 1"/>
@@ -3135,7 +3767,7 @@
               </a:defRPr>
             </a:pPr>
             <a:r>
-              <a:t>DASHSys 2026</a:t>
+              <a:t>Thank You!</a:t>
             </a:r>
           </a:p>
         </p:txBody>
@@ -3170,111 +3802,12 @@
               </a:defRPr>
             </a:pPr>
             <a:r>
-              <a:t>Workshop on Data-AI Systems</a:t>
-            </a:r>
-          </a:p>
-          <a:p>
-            <a:r>
-              <a:t>VLDB 2026 • Boston, MA</a:t>
-            </a:r>
-          </a:p>
-        </p:txBody>
-      </p:sp>
-    </p:spTree>
-  </p:cSld>
-  <p:clrMapOvr>
-    <a:masterClrMapping/>
-  </p:clrMapOvr>
-</p:sld>
-</file>
-
-<file path=ppt/slides/slide10.xml><?xml version="1.0" encoding="utf-8"?>
-<p:sld xmlns:a="http://schemas.openxmlformats.org/drawingml/2006/main" xmlns:p="http://schemas.openxmlformats.org/presentationml/2006/main" xmlns:r="http://schemas.openxmlformats.org/officeDocument/2006/relationships">
-  <p:cSld>
-    <p:bg>
-      <p:bgPr>
-        <a:solidFill>
-          <a:srgbClr val="1A2332"/>
-        </a:solidFill>
-        <a:effectLst/>
-      </p:bgPr>
-    </p:bg>
-    <p:spTree>
-      <p:nvGrpSpPr>
-        <p:cNvPr id="1" name=""/>
-        <p:cNvGrpSpPr/>
-        <p:nvPr/>
-      </p:nvGrpSpPr>
-      <p:grpSpPr/>
-      <p:sp>
-        <p:nvSpPr>
-          <p:cNvPr id="2" name="TextBox 1"/>
-          <p:cNvSpPr txBox="1"/>
-          <p:nvPr/>
-        </p:nvSpPr>
-        <p:spPr>
-          <a:xfrm>
-            <a:off x="914400" y="2286000"/>
-            <a:ext cx="10362895" cy="1371600"/>
-          </a:xfrm>
-          <a:prstGeom prst="rect">
-            <a:avLst/>
-          </a:prstGeom>
-          <a:noFill/>
-        </p:spPr>
-        <p:txBody>
-          <a:bodyPr wrap="none">
-            <a:spAutoFit/>
-          </a:bodyPr>
-          <a:lstStyle/>
-          <a:p>
-            <a:pPr algn="ctr">
-              <a:defRPr sz="5400" b="1">
-                <a:solidFill>
-                  <a:srgbClr val="FFFFFF"/>
-                </a:solidFill>
-              </a:defRPr>
-            </a:pPr>
-            <a:r>
-              <a:t>Thank You!</a:t>
-            </a:r>
-          </a:p>
-        </p:txBody>
-      </p:sp>
-      <p:sp>
-        <p:nvSpPr>
-          <p:cNvPr id="3" name="TextBox 2"/>
-          <p:cNvSpPr txBox="1"/>
-          <p:nvPr/>
-        </p:nvSpPr>
-        <p:spPr>
-          <a:xfrm>
-            <a:off x="914400" y="3840480"/>
-            <a:ext cx="10362895" cy="914400"/>
-          </a:xfrm>
-          <a:prstGeom prst="rect">
-            <a:avLst/>
-          </a:prstGeom>
-          <a:noFill/>
-        </p:spPr>
-        <p:txBody>
-          <a:bodyPr wrap="none">
-            <a:spAutoFit/>
-          </a:bodyPr>
-          <a:lstStyle/>
-          <a:p>
-            <a:pPr algn="ctr">
-              <a:defRPr sz="2800">
-                <a:solidFill>
-                  <a:srgbClr val="FFFFFF"/>
-                </a:solidFill>
-              </a:defRPr>
-            </a:pPr>
-            <a:r>
               <a:t>Let's build the future of data-AI systems — together.</a:t>
             </a:r>
           </a:p>
-          <a:p/>
+          <a:p>
+            <a:endParaRPr/>
+          </a:p>
           <a:p>
             <a:r>
               <a:t>#DASHSys2026</a:t>
@@ -3325,7 +3858,9 @@
               <a:t>💬 Questions: Submit anytime</a:t>
             </a:r>
           </a:p>
-          <a:p/>
+          <a:p>
+            <a:endParaRPr/>
+          </a:p>
           <a:p>
             <a:r>
               <a:t>Next: Eric Zhu - 'Surfing the Jagged Frontier'</a:t>
@@ -3342,7 +3877,335 @@
 </file>
 
 <file path=ppt/slides/slide2.xml><?xml version="1.0" encoding="utf-8"?>
-<p:sld xmlns:a="http://schemas.openxmlformats.org/drawingml/2006/main" xmlns:p="http://schemas.openxmlformats.org/presentationml/2006/main" xmlns:r="http://schemas.openxmlformats.org/officeDocument/2006/relationships">
+<p:sld xmlns:a="http://schemas.openxmlformats.org/drawingml/2006/main" xmlns:r="http://schemas.openxmlformats.org/officeDocument/2006/relationships" xmlns:p="http://schemas.openxmlformats.org/presentationml/2006/main">
+  <p:cSld>
+    <p:spTree>
+      <p:nvGrpSpPr>
+        <p:cNvPr id="1" name=""/>
+        <p:cNvGrpSpPr/>
+        <p:nvPr/>
+      </p:nvGrpSpPr>
+      <p:grpSpPr>
+        <a:xfrm>
+          <a:off x="0" y="0"/>
+          <a:ext cx="0" cy="0"/>
+          <a:chOff x="0" y="0"/>
+          <a:chExt cx="0" cy="0"/>
+        </a:xfrm>
+      </p:grpSpPr>
+      <p:sp>
+        <p:nvSpPr>
+          <p:cNvPr id="2" name="Title 1">
+            <a:extLst>
+              <a:ext uri="{FF2B5EF4-FFF2-40B4-BE49-F238E27FC236}">
+                <a16:creationId xmlns:a16="http://schemas.microsoft.com/office/drawing/2014/main" id="{BB52C102-2784-6E3B-2EB5-074A7AC5F3B3}"/>
+              </a:ext>
+            </a:extLst>
+          </p:cNvPr>
+          <p:cNvSpPr>
+            <a:spLocks noGrp="1"/>
+          </p:cNvSpPr>
+          <p:nvPr>
+            <p:ph type="title"/>
+          </p:nvPr>
+        </p:nvSpPr>
+        <p:spPr/>
+        <p:txBody>
+          <a:bodyPr/>
+          <a:lstStyle/>
+          <a:p>
+            <a:pPr algn="l"/>
+            <a:r>
+              <a:rPr lang="en-US" dirty="0" err="1"/>
+              <a:t>DASHSys</a:t>
+            </a:r>
+            <a:r>
+              <a:rPr lang="en-US" dirty="0"/>
+              <a:t>: First Edition</a:t>
+            </a:r>
+          </a:p>
+        </p:txBody>
+      </p:sp>
+      <p:sp>
+        <p:nvSpPr>
+          <p:cNvPr id="3" name="Content Placeholder 2">
+            <a:extLst>
+              <a:ext uri="{FF2B5EF4-FFF2-40B4-BE49-F238E27FC236}">
+                <a16:creationId xmlns:a16="http://schemas.microsoft.com/office/drawing/2014/main" id="{017243C6-B73C-6F6F-1C64-E1F5C512DCA4}"/>
+              </a:ext>
+            </a:extLst>
+          </p:cNvPr>
+          <p:cNvSpPr>
+            <a:spLocks noGrp="1"/>
+          </p:cNvSpPr>
+          <p:nvPr>
+            <p:ph idx="1"/>
+          </p:nvPr>
+        </p:nvSpPr>
+        <p:spPr>
+          <a:xfrm>
+            <a:off x="682284" y="2514600"/>
+            <a:ext cx="8110024" cy="1828800"/>
+          </a:xfrm>
+        </p:spPr>
+        <p:txBody>
+          <a:bodyPr>
+            <a:normAutofit/>
+          </a:bodyPr>
+          <a:lstStyle/>
+          <a:p>
+            <a:pPr>
+              <a:spcBef>
+                <a:spcPts val="1200"/>
+              </a:spcBef>
+              <a:defRPr sz="2400"/>
+            </a:pPr>
+            <a:r>
+              <a:rPr lang="en-US" dirty="0"/>
+              <a:t>DAIS - Data and AI Systems (2</a:t>
+            </a:r>
+            <a:r>
+              <a:rPr lang="en-US" baseline="30000" dirty="0"/>
+              <a:t>nd</a:t>
+            </a:r>
+            <a:r>
+              <a:rPr lang="en-US" dirty="0"/>
+              <a:t> Edition)</a:t>
+            </a:r>
+          </a:p>
+          <a:p>
+            <a:pPr>
+              <a:spcBef>
+                <a:spcPts val="1200"/>
+              </a:spcBef>
+              <a:defRPr sz="2400"/>
+            </a:pPr>
+            <a:r>
+              <a:rPr lang="en-US" dirty="0"/>
+              <a:t>DAAS - Data Management for Agentic AI Systems</a:t>
+            </a:r>
+          </a:p>
+          <a:p>
+            <a:pPr>
+              <a:spcBef>
+                <a:spcPts val="1200"/>
+              </a:spcBef>
+              <a:defRPr sz="2400"/>
+            </a:pPr>
+            <a:r>
+              <a:rPr lang="en-US" dirty="0"/>
+              <a:t>DASH - Data Systems with Human-in-the-loop AI (7</a:t>
+            </a:r>
+            <a:r>
+              <a:rPr lang="en-US" baseline="30000" dirty="0"/>
+              <a:t>th</a:t>
+            </a:r>
+            <a:r>
+              <a:rPr lang="en-US" dirty="0"/>
+              <a:t> Edition)</a:t>
+            </a:r>
+          </a:p>
+        </p:txBody>
+      </p:sp>
+      <p:pic>
+        <p:nvPicPr>
+          <p:cNvPr id="4" name="Picture 3">
+            <a:extLst>
+              <a:ext uri="{FF2B5EF4-FFF2-40B4-BE49-F238E27FC236}">
+                <a16:creationId xmlns:a16="http://schemas.microsoft.com/office/drawing/2014/main" id="{DBF5AE19-0F72-7324-E08E-ADF17297A6B4}"/>
+              </a:ext>
+            </a:extLst>
+          </p:cNvPr>
+          <p:cNvPicPr>
+            <a:picLocks noChangeAspect="1"/>
+          </p:cNvPicPr>
+          <p:nvPr/>
+        </p:nvPicPr>
+        <p:blipFill>
+          <a:blip r:embed="rId2"/>
+          <a:stretch>
+            <a:fillRect/>
+          </a:stretch>
+        </p:blipFill>
+        <p:spPr>
+          <a:xfrm>
+            <a:off x="8686800" y="2099603"/>
+            <a:ext cx="2658794" cy="2658794"/>
+          </a:xfrm>
+          <a:prstGeom prst="rect">
+            <a:avLst/>
+          </a:prstGeom>
+        </p:spPr>
+      </p:pic>
+      <p:pic>
+        <p:nvPicPr>
+          <p:cNvPr id="5" name="Picture 4" descr="Adobe">
+            <a:extLst>
+              <a:ext uri="{FF2B5EF4-FFF2-40B4-BE49-F238E27FC236}">
+                <a16:creationId xmlns:a16="http://schemas.microsoft.com/office/drawing/2014/main" id="{D9B57C3F-720B-2468-388E-135283CDDE01}"/>
+              </a:ext>
+            </a:extLst>
+          </p:cNvPr>
+          <p:cNvPicPr>
+            <a:picLocks noChangeAspect="1"/>
+          </p:cNvPicPr>
+          <p:nvPr/>
+        </p:nvPicPr>
+        <p:blipFill>
+          <a:blip r:embed="rId3"/>
+          <a:stretch>
+            <a:fillRect/>
+          </a:stretch>
+        </p:blipFill>
+        <p:spPr>
+          <a:xfrm>
+            <a:off x="4263291" y="4867421"/>
+            <a:ext cx="2698457" cy="1517882"/>
+          </a:xfrm>
+          <a:prstGeom prst="rect">
+            <a:avLst/>
+          </a:prstGeom>
+        </p:spPr>
+      </p:pic>
+      <p:sp>
+        <p:nvSpPr>
+          <p:cNvPr id="6" name="TextBox 5">
+            <a:extLst>
+              <a:ext uri="{FF2B5EF4-FFF2-40B4-BE49-F238E27FC236}">
+                <a16:creationId xmlns:a16="http://schemas.microsoft.com/office/drawing/2014/main" id="{AB579033-272F-672C-B0BD-E28094F5EE40}"/>
+              </a:ext>
+            </a:extLst>
+          </p:cNvPr>
+          <p:cNvSpPr txBox="1"/>
+          <p:nvPr/>
+        </p:nvSpPr>
+        <p:spPr>
+          <a:xfrm>
+            <a:off x="2025748" y="5514535"/>
+            <a:ext cx="1545038" cy="369332"/>
+          </a:xfrm>
+          <a:prstGeom prst="rect">
+            <a:avLst/>
+          </a:prstGeom>
+          <a:noFill/>
+        </p:spPr>
+        <p:txBody>
+          <a:bodyPr wrap="none" rtlCol="0">
+            <a:spAutoFit/>
+          </a:bodyPr>
+          <a:lstStyle/>
+          <a:p>
+            <a:r>
+              <a:rPr lang="en-US" b="1" dirty="0"/>
+              <a:t>Sponsored by:</a:t>
+            </a:r>
+          </a:p>
+        </p:txBody>
+      </p:sp>
+    </p:spTree>
+    <p:extLst>
+      <p:ext uri="{BB962C8B-B14F-4D97-AF65-F5344CB8AC3E}">
+        <p14:creationId xmlns:p14="http://schemas.microsoft.com/office/powerpoint/2010/main" val="501504255"/>
+      </p:ext>
+    </p:extLst>
+  </p:cSld>
+  <p:clrMapOvr>
+    <a:masterClrMapping/>
+  </p:clrMapOvr>
+</p:sld>
+</file>
+
+<file path=ppt/slides/slide3.xml><?xml version="1.0" encoding="utf-8"?>
+<p:sld xmlns:a="http://schemas.openxmlformats.org/drawingml/2006/main" xmlns:r="http://schemas.openxmlformats.org/officeDocument/2006/relationships" xmlns:p="http://schemas.openxmlformats.org/presentationml/2006/main">
+  <p:cSld>
+    <p:spTree>
+      <p:nvGrpSpPr>
+        <p:cNvPr id="1" name=""/>
+        <p:cNvGrpSpPr/>
+        <p:nvPr/>
+      </p:nvGrpSpPr>
+      <p:grpSpPr>
+        <a:xfrm>
+          <a:off x="0" y="0"/>
+          <a:ext cx="0" cy="0"/>
+          <a:chOff x="0" y="0"/>
+          <a:chExt cx="0" cy="0"/>
+        </a:xfrm>
+      </p:grpSpPr>
+      <p:sp>
+        <p:nvSpPr>
+          <p:cNvPr id="2" name="Title 1">
+            <a:extLst>
+              <a:ext uri="{FF2B5EF4-FFF2-40B4-BE49-F238E27FC236}">
+                <a16:creationId xmlns:a16="http://schemas.microsoft.com/office/drawing/2014/main" id="{47550A02-F493-10DD-996A-BC28F7D71C79}"/>
+              </a:ext>
+            </a:extLst>
+          </p:cNvPr>
+          <p:cNvSpPr>
+            <a:spLocks noGrp="1"/>
+          </p:cNvSpPr>
+          <p:nvPr>
+            <p:ph type="title"/>
+          </p:nvPr>
+        </p:nvSpPr>
+        <p:spPr/>
+        <p:txBody>
+          <a:bodyPr/>
+          <a:lstStyle/>
+          <a:p>
+            <a:pPr algn="l"/>
+            <a:r>
+              <a:rPr lang="en-US" dirty="0"/>
+              <a:t>Organizers</a:t>
+            </a:r>
+          </a:p>
+        </p:txBody>
+      </p:sp>
+      <p:pic>
+        <p:nvPicPr>
+          <p:cNvPr id="5" name="Picture 4">
+            <a:extLst>
+              <a:ext uri="{FF2B5EF4-FFF2-40B4-BE49-F238E27FC236}">
+                <a16:creationId xmlns:a16="http://schemas.microsoft.com/office/drawing/2014/main" id="{98FCCC3C-B9E2-9C33-A449-6E0095912416}"/>
+              </a:ext>
+            </a:extLst>
+          </p:cNvPr>
+          <p:cNvPicPr>
+            <a:picLocks noChangeAspect="1"/>
+          </p:cNvPicPr>
+          <p:nvPr/>
+        </p:nvPicPr>
+        <p:blipFill>
+          <a:blip r:embed="rId2"/>
+          <a:stretch>
+            <a:fillRect/>
+          </a:stretch>
+        </p:blipFill>
+        <p:spPr>
+          <a:xfrm>
+            <a:off x="914400" y="1417638"/>
+            <a:ext cx="9830364" cy="4139100"/>
+          </a:xfrm>
+          <a:prstGeom prst="rect">
+            <a:avLst/>
+          </a:prstGeom>
+        </p:spPr>
+      </p:pic>
+    </p:spTree>
+    <p:extLst>
+      <p:ext uri="{BB962C8B-B14F-4D97-AF65-F5344CB8AC3E}">
+        <p14:creationId xmlns:p14="http://schemas.microsoft.com/office/powerpoint/2010/main" val="2973259279"/>
+      </p:ext>
+    </p:extLst>
+  </p:cSld>
+  <p:clrMapOvr>
+    <a:masterClrMapping/>
+  </p:clrMapOvr>
+</p:sld>
+</file>
+
+<file path=ppt/slides/slide4.xml><?xml version="1.0" encoding="utf-8"?>
+<p:sld xmlns:a="http://schemas.openxmlformats.org/drawingml/2006/main" xmlns:r="http://schemas.openxmlformats.org/officeDocument/2006/relationships" xmlns:p="http://schemas.openxmlformats.org/presentationml/2006/main">
   <p:cSld>
     <p:bg>
       <p:bgPr>
@@ -3358,7 +4221,14 @@
         <p:cNvGrpSpPr/>
         <p:nvPr/>
       </p:nvGrpSpPr>
-      <p:grpSpPr/>
+      <p:grpSpPr>
+        <a:xfrm>
+          <a:off x="0" y="0"/>
+          <a:ext cx="0" cy="0"/>
+          <a:chOff x="0" y="0"/>
+          <a:chExt cx="0" cy="0"/>
+        </a:xfrm>
+      </p:grpSpPr>
       <p:sp>
         <p:nvSpPr>
           <p:cNvPr id="2" name="TextBox 1"/>
@@ -3368,7 +4238,7 @@
         <p:spPr>
           <a:xfrm>
             <a:off x="457200" y="274320"/>
-            <a:ext cx="11277295" cy="731520"/>
+            <a:ext cx="5583388" cy="707886"/>
           </a:xfrm>
           <a:prstGeom prst="rect">
             <a:avLst/>
@@ -3389,7 +4259,16 @@
               </a:defRPr>
             </a:pPr>
             <a:r>
-              <a:t>The Convergence Story: How DASHSys Was Born</a:t>
+              <a:rPr lang="en-US" dirty="0" err="1"/>
+              <a:t>DASHSys</a:t>
+            </a:r>
+            <a:r>
+              <a:rPr lang="en-US" dirty="0"/>
+              <a:t> </a:t>
+            </a:r>
+            <a:r>
+              <a:rPr dirty="0"/>
+              <a:t>By the Numbers</a:t>
             </a:r>
           </a:p>
         </p:txBody>
@@ -3403,7 +4282,7 @@
         <p:spPr>
           <a:xfrm>
             <a:off x="914400" y="1371600"/>
-            <a:ext cx="10362895" cy="5029200"/>
+            <a:ext cx="10362895" cy="3600986"/>
           </a:xfrm>
           <a:prstGeom prst="rect">
             <a:avLst/>
@@ -3423,104 +4302,137 @@
               <a:defRPr sz="2400"/>
             </a:pPr>
             <a:r>
-              <a:t>🔵 DAIS - Data and AI Systems</a:t>
-            </a:r>
-          </a:p>
-          <a:p>
-            <a:pPr>
-              <a:spcBef>
-                <a:spcPts val="1200"/>
-              </a:spcBef>
-              <a:defRPr sz="2400"/>
-            </a:pPr>
-            <a:r>
-              <a:t>🟣 DAAS - Data Management for Agentic AI Systems</a:t>
-            </a:r>
-          </a:p>
-          <a:p>
-            <a:pPr>
-              <a:spcBef>
-                <a:spcPts val="1200"/>
-              </a:spcBef>
-              <a:defRPr sz="2400"/>
-            </a:pPr>
-            <a:r>
-              <a:t>🟢 DASH - Data Systems with Human-in-the-loop AI</a:t>
-            </a:r>
-          </a:p>
-          <a:p>
-            <a:pPr>
-              <a:spcBef>
-                <a:spcPts val="1200"/>
-              </a:spcBef>
-              <a:defRPr sz="2400"/>
-            </a:pPr>
-          </a:p>
-          <a:p>
-            <a:pPr>
-              <a:spcBef>
-                <a:spcPts val="1200"/>
-              </a:spcBef>
-              <a:defRPr sz="2400"/>
-            </a:pPr>
-            <a:r>
-              <a:t>➡️  Three workshops with overlapping interests</a:t>
-            </a:r>
-          </a:p>
-          <a:p>
-            <a:pPr>
-              <a:spcBef>
-                <a:spcPts val="1200"/>
-              </a:spcBef>
-              <a:defRPr sz="2400"/>
-            </a:pPr>
-            <a:r>
-              <a:t>➡️  VLDB asked: Why not merge?</a:t>
-            </a:r>
-          </a:p>
-          <a:p>
-            <a:pPr>
-              <a:spcBef>
-                <a:spcPts val="1200"/>
-              </a:spcBef>
-              <a:defRPr sz="2400"/>
-            </a:pPr>
-            <a:r>
-              <a:t>➡️  Result: DASHSys - One unified community</a:t>
-            </a:r>
-          </a:p>
-          <a:p>
-            <a:pPr>
-              <a:spcBef>
-                <a:spcPts val="1200"/>
-              </a:spcBef>
-              <a:defRPr sz="2400"/>
-            </a:pPr>
-          </a:p>
-          <a:p>
-            <a:pPr>
-              <a:spcBef>
-                <a:spcPts val="1200"/>
-              </a:spcBef>
-              <a:defRPr sz="2400"/>
-            </a:pPr>
-            <a:r>
-              <a:t>💡 The convergence itself is the message:</a:t>
-            </a:r>
-          </a:p>
-          <a:p>
-            <a:pPr>
-              <a:spcBef>
-                <a:spcPts val="1200"/>
-              </a:spcBef>
-              <a:defRPr sz="2400"/>
-            </a:pPr>
-            <a:r>
-              <a:t>   This is where the field is heading.</a:t>
-            </a:r>
-          </a:p>
-        </p:txBody>
-      </p:sp>
+              <a:rPr dirty="0"/>
+              <a:t>• </a:t>
+            </a:r>
+            <a:r>
+              <a:rPr lang="en-US" dirty="0"/>
+              <a:t>35 Total submission</a:t>
+            </a:r>
+            <a:endParaRPr dirty="0"/>
+          </a:p>
+          <a:p>
+            <a:pPr>
+              <a:spcBef>
+                <a:spcPts val="1200"/>
+              </a:spcBef>
+              <a:defRPr sz="2400"/>
+            </a:pPr>
+            <a:r>
+              <a:rPr dirty="0"/>
+              <a:t>   • Regular Track: 23 papers</a:t>
+            </a:r>
+            <a:endParaRPr lang="en-US" dirty="0"/>
+          </a:p>
+          <a:p>
+            <a:pPr>
+              <a:spcBef>
+                <a:spcPts val="1200"/>
+              </a:spcBef>
+              <a:defRPr sz="2400"/>
+            </a:pPr>
+            <a:r>
+              <a:rPr lang="en-US" dirty="0"/>
+              <a:t>         4 long papers</a:t>
+            </a:r>
+          </a:p>
+          <a:p>
+            <a:pPr>
+              <a:spcBef>
+                <a:spcPts val="1200"/>
+              </a:spcBef>
+              <a:defRPr sz="2400"/>
+            </a:pPr>
+            <a:r>
+              <a:rPr lang="en-US" dirty="0"/>
+              <a:t>         8 posters</a:t>
+            </a:r>
+            <a:endParaRPr dirty="0"/>
+          </a:p>
+          <a:p>
+            <a:pPr>
+              <a:spcBef>
+                <a:spcPts val="1200"/>
+              </a:spcBef>
+              <a:defRPr sz="2400"/>
+            </a:pPr>
+            <a:r>
+              <a:rPr dirty="0"/>
+              <a:t>   • System Track: 12 </a:t>
+            </a:r>
+            <a:r>
+              <a:rPr lang="en-US" dirty="0"/>
+              <a:t>agents</a:t>
+            </a:r>
+          </a:p>
+          <a:p>
+            <a:pPr>
+              <a:spcBef>
+                <a:spcPts val="1200"/>
+              </a:spcBef>
+              <a:defRPr sz="2400"/>
+            </a:pPr>
+            <a:r>
+              <a:rPr lang="en-US" dirty="0"/>
+              <a:t>	</a:t>
+            </a:r>
+            <a:r>
+              <a:rPr dirty="0"/>
+              <a:t>1st Place: IBM Research Zurich</a:t>
+            </a:r>
+          </a:p>
+          <a:p>
+            <a:pPr>
+              <a:spcBef>
+                <a:spcPts val="1200"/>
+              </a:spcBef>
+              <a:defRPr sz="2400"/>
+            </a:pPr>
+            <a:r>
+              <a:rPr dirty="0"/>
+              <a:t>   </a:t>
+            </a:r>
+            <a:r>
+              <a:rPr lang="en-US" dirty="0"/>
+              <a:t>    </a:t>
+            </a:r>
+            <a:r>
+              <a:rPr dirty="0"/>
+              <a:t>2nd Place: Princeton University</a:t>
+            </a:r>
+          </a:p>
+        </p:txBody>
+      </p:sp>
+      <p:pic>
+        <p:nvPicPr>
+          <p:cNvPr id="6" name="Picture 5">
+            <a:extLst>
+              <a:ext uri="{FF2B5EF4-FFF2-40B4-BE49-F238E27FC236}">
+                <a16:creationId xmlns:a16="http://schemas.microsoft.com/office/drawing/2014/main" id="{D99ACA7A-85BE-F6B6-1C2C-A5A15E00788A}"/>
+              </a:ext>
+            </a:extLst>
+          </p:cNvPr>
+          <p:cNvPicPr>
+            <a:picLocks noChangeAspect="1"/>
+          </p:cNvPicPr>
+          <p:nvPr/>
+        </p:nvPicPr>
+        <p:blipFill>
+          <a:blip r:embed="rId2"/>
+          <a:stretch>
+            <a:fillRect/>
+          </a:stretch>
+        </p:blipFill>
+        <p:spPr>
+          <a:xfrm>
+            <a:off x="6737564" y="1181686"/>
+            <a:ext cx="2769821" cy="5057335"/>
+          </a:xfrm>
+          <a:prstGeom prst="rect">
+            <a:avLst/>
+          </a:prstGeom>
+        </p:spPr>
+      </p:pic>
     </p:spTree>
   </p:cSld>
   <p:clrMapOvr>
@@ -3529,8 +4441,8 @@
 </p:sld>
 </file>
 
-<file path=ppt/slides/slide3.xml><?xml version="1.0" encoding="utf-8"?>
-<p:sld xmlns:a="http://schemas.openxmlformats.org/drawingml/2006/main" xmlns:p="http://schemas.openxmlformats.org/presentationml/2006/main" xmlns:r="http://schemas.openxmlformats.org/officeDocument/2006/relationships">
+<file path=ppt/slides/slide5.xml><?xml version="1.0" encoding="utf-8"?>
+<p:sld xmlns:a="http://schemas.openxmlformats.org/drawingml/2006/main" xmlns:r="http://schemas.openxmlformats.org/officeDocument/2006/relationships" xmlns:p="http://schemas.openxmlformats.org/presentationml/2006/main">
   <p:cSld>
     <p:bg>
       <p:bgPr>
@@ -3546,7 +4458,14 @@
         <p:cNvGrpSpPr/>
         <p:nvPr/>
       </p:nvGrpSpPr>
-      <p:grpSpPr/>
+      <p:grpSpPr>
+        <a:xfrm>
+          <a:off x="0" y="0"/>
+          <a:ext cx="0" cy="0"/>
+          <a:chOff x="0" y="0"/>
+          <a:chExt cx="0" cy="0"/>
+        </a:xfrm>
+      </p:grpSpPr>
       <p:sp>
         <p:nvSpPr>
           <p:cNvPr id="2" name="TextBox 1"/>
@@ -3577,7 +4496,7 @@
               </a:defRPr>
             </a:pPr>
             <a:r>
-              <a:t>By the Numbers: Strong Response</a:t>
+              <a:t>Today's Program</a:t>
             </a:r>
           </a:p>
         </p:txBody>
@@ -3591,7 +4510,7 @@
         <p:spPr>
           <a:xfrm>
             <a:off x="914400" y="1371600"/>
-            <a:ext cx="10362895" cy="5029200"/>
+            <a:ext cx="10362895" cy="5170646"/>
           </a:xfrm>
           <a:prstGeom prst="rect">
             <a:avLst/>
@@ -3611,144 +4530,154 @@
               <a:defRPr sz="2400"/>
             </a:pPr>
             <a:r>
-              <a:t>📊 SUBMISSIONS</a:t>
-            </a:r>
-          </a:p>
-          <a:p>
-            <a:pPr>
-              <a:spcBef>
-                <a:spcPts val="1200"/>
-              </a:spcBef>
-              <a:defRPr sz="2400"/>
-            </a:pPr>
-            <a:r>
-              <a:t>   • 35 total papers submitted</a:t>
-            </a:r>
-          </a:p>
-          <a:p>
-            <a:pPr>
-              <a:spcBef>
-                <a:spcPts val="1200"/>
-              </a:spcBef>
-              <a:defRPr sz="2400"/>
-            </a:pPr>
-            <a:r>
-              <a:t>   • Regular Track: 23 papers</a:t>
-            </a:r>
-          </a:p>
-          <a:p>
-            <a:pPr>
-              <a:spcBef>
-                <a:spcPts val="1200"/>
-              </a:spcBef>
-              <a:defRPr sz="2400"/>
-            </a:pPr>
-            <a:r>
-              <a:t>   • System Track: 12 papers</a:t>
-            </a:r>
-          </a:p>
-          <a:p>
-            <a:pPr>
-              <a:spcBef>
-                <a:spcPts val="1200"/>
-              </a:spcBef>
-              <a:defRPr sz="2400"/>
-            </a:pPr>
-          </a:p>
-          <a:p>
-            <a:pPr>
-              <a:spcBef>
-                <a:spcPts val="1200"/>
-              </a:spcBef>
-              <a:defRPr sz="2400"/>
-            </a:pPr>
-            <a:r>
-              <a:t>✅ ACCEPTED</a:t>
-            </a:r>
-          </a:p>
-          <a:p>
-            <a:pPr>
-              <a:spcBef>
-                <a:spcPts val="1200"/>
-              </a:spcBef>
-              <a:defRPr sz="2400"/>
-            </a:pPr>
-            <a:r>
-              <a:t>   • 12 regular papers (40% acceptance rate)</a:t>
-            </a:r>
-          </a:p>
-          <a:p>
-            <a:pPr>
-              <a:spcBef>
-                <a:spcPts val="1200"/>
-              </a:spcBef>
-              <a:defRPr sz="2400"/>
-            </a:pPr>
-            <a:r>
-              <a:t>     - 4 long papers (8 minutes each)</a:t>
-            </a:r>
-          </a:p>
-          <a:p>
-            <a:pPr>
-              <a:spcBef>
-                <a:spcPts val="1200"/>
-              </a:spcBef>
-              <a:defRPr sz="2400"/>
-            </a:pPr>
-            <a:r>
-              <a:t>     - 8 short papers (4 minutes each)</a:t>
-            </a:r>
-          </a:p>
-          <a:p>
-            <a:pPr>
-              <a:spcBef>
-                <a:spcPts val="1200"/>
-              </a:spcBef>
-              <a:defRPr sz="2400"/>
-            </a:pPr>
-            <a:r>
-              <a:t>   • 2 system track winners</a:t>
-            </a:r>
-          </a:p>
-          <a:p>
-            <a:pPr>
-              <a:spcBef>
-                <a:spcPts val="1200"/>
-              </a:spcBef>
-              <a:defRPr sz="2400"/>
-            </a:pPr>
-          </a:p>
-          <a:p>
-            <a:pPr>
-              <a:spcBef>
-                <a:spcPts val="1200"/>
-              </a:spcBef>
-              <a:defRPr sz="2400"/>
-            </a:pPr>
-            <a:r>
-              <a:t>🏆 COMPETITION WINNERS</a:t>
-            </a:r>
-          </a:p>
-          <a:p>
-            <a:pPr>
-              <a:spcBef>
-                <a:spcPts val="1200"/>
-              </a:spcBef>
-              <a:defRPr sz="2400"/>
-            </a:pPr>
-            <a:r>
-              <a:t>   • 1st Place: IBM Research Zurich</a:t>
-            </a:r>
-          </a:p>
-          <a:p>
-            <a:pPr>
-              <a:spcBef>
-                <a:spcPts val="1200"/>
-              </a:spcBef>
-              <a:defRPr sz="2400"/>
-            </a:pPr>
-            <a:r>
-              <a:t>   • 2nd Place: Princeton University</a:t>
+              <a:rPr dirty="0"/>
+              <a:t>09:00-09:10  Welcome &amp; Opening (now!)</a:t>
+            </a:r>
+          </a:p>
+          <a:p>
+            <a:pPr>
+              <a:spcBef>
+                <a:spcPts val="1200"/>
+              </a:spcBef>
+              <a:defRPr sz="2400"/>
+            </a:pPr>
+            <a:r>
+              <a:rPr dirty="0"/>
+              <a:t>09:10-10:30  Keynote Session 1 (Eric Zhu, Fatma Özcan)</a:t>
+            </a:r>
+          </a:p>
+          <a:p>
+            <a:pPr>
+              <a:spcBef>
+                <a:spcPts val="1200"/>
+              </a:spcBef>
+              <a:defRPr sz="2400"/>
+            </a:pPr>
+            <a:r>
+              <a:rPr dirty="0"/>
+              <a:t>10:30-11:00  ☕ Coffee Break + Posters</a:t>
+            </a:r>
+          </a:p>
+          <a:p>
+            <a:pPr>
+              <a:spcBef>
+                <a:spcPts val="1200"/>
+              </a:spcBef>
+              <a:defRPr sz="2400"/>
+            </a:pPr>
+            <a:r>
+              <a:rPr dirty="0"/>
+              <a:t>11:00-12:30  📄 Long Papers (4 × 8 min)</a:t>
+            </a:r>
+          </a:p>
+          <a:p>
+            <a:pPr>
+              <a:spcBef>
+                <a:spcPts val="1200"/>
+              </a:spcBef>
+              <a:defRPr sz="2400"/>
+            </a:pPr>
+            <a:r>
+              <a:rPr dirty="0"/>
+              <a:t>12:30-14:00  🍽️  Lunch Break</a:t>
+            </a:r>
+          </a:p>
+          <a:p>
+            <a:pPr>
+              <a:spcBef>
+                <a:spcPts val="1200"/>
+              </a:spcBef>
+              <a:defRPr sz="2400"/>
+            </a:pPr>
+            <a:r>
+              <a:rPr dirty="0"/>
+              <a:t>14:00-15:30  Keynote Session 2 (Omar Khattab, Eugene Wu)</a:t>
+            </a:r>
+          </a:p>
+          <a:p>
+            <a:pPr>
+              <a:spcBef>
+                <a:spcPts val="1200"/>
+              </a:spcBef>
+              <a:defRPr sz="2400"/>
+            </a:pPr>
+            <a:r>
+              <a:rPr dirty="0"/>
+              <a:t>15:30-16:00  ☕ Coffee Break + Posters</a:t>
+            </a:r>
+          </a:p>
+          <a:p>
+            <a:pPr>
+              <a:spcBef>
+                <a:spcPts val="1200"/>
+              </a:spcBef>
+              <a:defRPr sz="2400"/>
+            </a:pPr>
+            <a:r>
+              <a:rPr dirty="0"/>
+              <a:t>16:00-17:15  📄 Short Papers (8 × 4 min)</a:t>
+            </a:r>
+          </a:p>
+          <a:p>
+            <a:pPr>
+              <a:spcBef>
+                <a:spcPts val="1200"/>
+              </a:spcBef>
+              <a:defRPr sz="2400"/>
+            </a:pPr>
+            <a:r>
+              <a:rPr dirty="0"/>
+              <a:t>17:15-18:00  💬 Panel Discussion + Closing</a:t>
+            </a:r>
+          </a:p>
+          <a:p>
+            <a:pPr>
+              <a:spcBef>
+                <a:spcPts val="1200"/>
+              </a:spcBef>
+              <a:defRPr sz="2400"/>
+            </a:pPr>
+            <a:endParaRPr dirty="0"/>
+          </a:p>
+        </p:txBody>
+      </p:sp>
+      <p:sp>
+        <p:nvSpPr>
+          <p:cNvPr id="5" name="TextBox 4">
+            <a:extLst>
+              <a:ext uri="{FF2B5EF4-FFF2-40B4-BE49-F238E27FC236}">
+                <a16:creationId xmlns:a16="http://schemas.microsoft.com/office/drawing/2014/main" id="{8BFC4EF3-BA6B-3C1B-FB83-701643919D04}"/>
+              </a:ext>
+            </a:extLst>
+          </p:cNvPr>
+          <p:cNvSpPr txBox="1"/>
+          <p:nvPr/>
+        </p:nvSpPr>
+        <p:spPr>
+          <a:xfrm>
+            <a:off x="1318845" y="6311413"/>
+            <a:ext cx="7487530" cy="461665"/>
+          </a:xfrm>
+          <a:prstGeom prst="rect">
+            <a:avLst/>
+          </a:prstGeom>
+          <a:noFill/>
+        </p:spPr>
+        <p:txBody>
+          <a:bodyPr wrap="square">
+            <a:spAutoFit/>
+          </a:bodyPr>
+          <a:lstStyle/>
+          <a:p>
+            <a:pPr>
+              <a:spcBef>
+                <a:spcPts val="1200"/>
+              </a:spcBef>
+              <a:defRPr sz="2400"/>
+            </a:pPr>
+            <a:r>
+              <a:rPr lang="en-US" sz="2400" dirty="0"/>
+              <a:t>***All 12 papers + 2 systems demos at poster sessions!</a:t>
             </a:r>
           </a:p>
         </p:txBody>
@@ -3761,8 +4690,8 @@
 </p:sld>
 </file>
 
-<file path=ppt/slides/slide4.xml><?xml version="1.0" encoding="utf-8"?>
-<p:sld xmlns:a="http://schemas.openxmlformats.org/drawingml/2006/main" xmlns:p="http://schemas.openxmlformats.org/presentationml/2006/main" xmlns:r="http://schemas.openxmlformats.org/officeDocument/2006/relationships">
+<file path=ppt/slides/slide6.xml><?xml version="1.0" encoding="utf-8"?>
+<p:sld xmlns:a="http://schemas.openxmlformats.org/drawingml/2006/main" xmlns:r="http://schemas.openxmlformats.org/officeDocument/2006/relationships" xmlns:p="http://schemas.openxmlformats.org/presentationml/2006/main">
   <p:cSld>
     <p:bg>
       <p:bgPr>
@@ -3778,7 +4707,14 @@
         <p:cNvGrpSpPr/>
         <p:nvPr/>
       </p:nvGrpSpPr>
-      <p:grpSpPr/>
+      <p:grpSpPr>
+        <a:xfrm>
+          <a:off x="0" y="0"/>
+          <a:ext cx="0" cy="0"/>
+          <a:chOff x="0" y="0"/>
+          <a:chExt cx="0" cy="0"/>
+        </a:xfrm>
+      </p:grpSpPr>
       <p:sp>
         <p:nvSpPr>
           <p:cNvPr id="2" name="TextBox 1"/>
@@ -3809,7 +4745,7 @@
               </a:defRPr>
             </a:pPr>
             <a:r>
-              <a:t>Today's Program</a:t>
+              <a:t>Four Core Research Themes</a:t>
             </a:r>
           </a:p>
         </p:txBody>
@@ -3843,114 +4779,155 @@
               <a:defRPr sz="2400"/>
             </a:pPr>
             <a:r>
-              <a:t>09:00-09:10  Welcome &amp; Opening (now!)</a:t>
-            </a:r>
-          </a:p>
-          <a:p>
-            <a:pPr>
-              <a:spcBef>
-                <a:spcPts val="1200"/>
-              </a:spcBef>
-              <a:defRPr sz="2400"/>
-            </a:pPr>
-            <a:r>
-              <a:t>09:10-10:30  Keynote Session 1 (Eric Zhu, Fatma Özcan)</a:t>
-            </a:r>
-          </a:p>
-          <a:p>
-            <a:pPr>
-              <a:spcBef>
-                <a:spcPts val="1200"/>
-              </a:spcBef>
-              <a:defRPr sz="2400"/>
-            </a:pPr>
-            <a:r>
-              <a:t>10:30-11:00  ☕ Coffee Break + Posters</a:t>
-            </a:r>
-          </a:p>
-          <a:p>
-            <a:pPr>
-              <a:spcBef>
-                <a:spcPts val="1200"/>
-              </a:spcBef>
-              <a:defRPr sz="2400"/>
-            </a:pPr>
-            <a:r>
-              <a:t>11:00-12:30  📄 Long Papers (4 × 8 min)</a:t>
-            </a:r>
-          </a:p>
-          <a:p>
-            <a:pPr>
-              <a:spcBef>
-                <a:spcPts val="1200"/>
-              </a:spcBef>
-              <a:defRPr sz="2400"/>
-            </a:pPr>
-            <a:r>
-              <a:t>12:30-14:00  🍽️  Lunch Break</a:t>
-            </a:r>
-          </a:p>
-          <a:p>
-            <a:pPr>
-              <a:spcBef>
-                <a:spcPts val="1200"/>
-              </a:spcBef>
-              <a:defRPr sz="2400"/>
-            </a:pPr>
-            <a:r>
-              <a:t>14:00-15:30  Keynote Session 2 (Omar Khattab, Eugene Wu)</a:t>
-            </a:r>
-          </a:p>
-          <a:p>
-            <a:pPr>
-              <a:spcBef>
-                <a:spcPts val="1200"/>
-              </a:spcBef>
-              <a:defRPr sz="2400"/>
-            </a:pPr>
-            <a:r>
-              <a:t>15:30-16:00  ☕ Coffee Break + Posters</a:t>
-            </a:r>
-          </a:p>
-          <a:p>
-            <a:pPr>
-              <a:spcBef>
-                <a:spcPts val="1200"/>
-              </a:spcBef>
-              <a:defRPr sz="2400"/>
-            </a:pPr>
-            <a:r>
-              <a:t>16:00-17:15  📄 Short Papers (8 × 4 min)</a:t>
-            </a:r>
-          </a:p>
-          <a:p>
-            <a:pPr>
-              <a:spcBef>
-                <a:spcPts val="1200"/>
-              </a:spcBef>
-              <a:defRPr sz="2400"/>
-            </a:pPr>
-            <a:r>
-              <a:t>17:15-18:00  💬 Panel Discussion + Closing</a:t>
-            </a:r>
-          </a:p>
-          <a:p>
-            <a:pPr>
-              <a:spcBef>
-                <a:spcPts val="1200"/>
-              </a:spcBef>
-              <a:defRPr sz="2400"/>
-            </a:pPr>
-          </a:p>
-          <a:p>
-            <a:pPr>
-              <a:spcBef>
-                <a:spcPts val="1200"/>
-              </a:spcBef>
-              <a:defRPr sz="2400"/>
-            </a:pPr>
-            <a:r>
-              <a:t>🎯 All 12 papers + 2 systems demos at poster sessions!</a:t>
+              <a:t>🔵 42% Data Management for Agentic Systems</a:t>
+            </a:r>
+          </a:p>
+          <a:p>
+            <a:pPr>
+              <a:spcBef>
+                <a:spcPts val="1200"/>
+              </a:spcBef>
+              <a:defRPr sz="2400"/>
+            </a:pPr>
+            <a:r>
+              <a:t>   Building the infrastructure agents need</a:t>
+            </a:r>
+          </a:p>
+          <a:p>
+            <a:pPr>
+              <a:spcBef>
+                <a:spcPts val="1200"/>
+              </a:spcBef>
+              <a:defRPr sz="2400"/>
+            </a:pPr>
+            <a:r>
+              <a:t>   (GitLake, Data Canvas, Structured State Management)</a:t>
+            </a:r>
+          </a:p>
+          <a:p>
+            <a:pPr>
+              <a:spcBef>
+                <a:spcPts val="1200"/>
+              </a:spcBef>
+              <a:defRPr sz="2400"/>
+            </a:pPr>
+            <a:endParaRPr/>
+          </a:p>
+          <a:p>
+            <a:pPr>
+              <a:spcBef>
+                <a:spcPts val="1200"/>
+              </a:spcBef>
+              <a:defRPr sz="2400"/>
+            </a:pPr>
+            <a:r>
+              <a:t>🟣 25% Agentic Systems for Data Management</a:t>
+            </a:r>
+          </a:p>
+          <a:p>
+            <a:pPr>
+              <a:spcBef>
+                <a:spcPts val="1200"/>
+              </a:spcBef>
+              <a:defRPr sz="2400"/>
+            </a:pPr>
+            <a:r>
+              <a:t>   Agents that help manage and discover data</a:t>
+            </a:r>
+          </a:p>
+          <a:p>
+            <a:pPr>
+              <a:spcBef>
+                <a:spcPts val="1200"/>
+              </a:spcBef>
+              <a:defRPr sz="2400"/>
+            </a:pPr>
+            <a:r>
+              <a:t>   (ASMR, GUIDE, Multi-agent Framework)</a:t>
+            </a:r>
+          </a:p>
+          <a:p>
+            <a:pPr>
+              <a:spcBef>
+                <a:spcPts val="1200"/>
+              </a:spcBef>
+              <a:defRPr sz="2400"/>
+            </a:pPr>
+            <a:endParaRPr/>
+          </a:p>
+          <a:p>
+            <a:pPr>
+              <a:spcBef>
+                <a:spcPts val="1200"/>
+              </a:spcBef>
+              <a:defRPr sz="2400"/>
+            </a:pPr>
+            <a:r>
+              <a:t>🟢 42% Human-Centered &amp; Human-in-the-Loop</a:t>
+            </a:r>
+          </a:p>
+          <a:p>
+            <a:pPr>
+              <a:spcBef>
+                <a:spcPts val="1200"/>
+              </a:spcBef>
+              <a:defRPr sz="2400"/>
+            </a:pPr>
+            <a:r>
+              <a:t>   Keeping humans in control</a:t>
+            </a:r>
+          </a:p>
+          <a:p>
+            <a:pPr>
+              <a:spcBef>
+                <a:spcPts val="1200"/>
+              </a:spcBef>
+              <a:defRPr sz="2400"/>
+            </a:pPr>
+            <a:r>
+              <a:t>   (Walk Before You Run, AgentTrails, Be Fair!)</a:t>
+            </a:r>
+          </a:p>
+          <a:p>
+            <a:pPr>
+              <a:spcBef>
+                <a:spcPts val="1200"/>
+              </a:spcBef>
+              <a:defRPr sz="2400"/>
+            </a:pPr>
+            <a:endParaRPr/>
+          </a:p>
+          <a:p>
+            <a:pPr>
+              <a:spcBef>
+                <a:spcPts val="1200"/>
+              </a:spcBef>
+              <a:defRPr sz="2400"/>
+            </a:pPr>
+            <a:r>
+              <a:t>🔴 8% Evaluation, Reliability &amp; Learning</a:t>
+            </a:r>
+          </a:p>
+          <a:p>
+            <a:pPr>
+              <a:spcBef>
+                <a:spcPts val="1200"/>
+              </a:spcBef>
+              <a:defRPr sz="2400"/>
+            </a:pPr>
+            <a:r>
+              <a:t>   How to measure and trust these systems (SANA)</a:t>
+            </a:r>
+          </a:p>
+          <a:p>
+            <a:pPr>
+              <a:spcBef>
+                <a:spcPts val="1200"/>
+              </a:spcBef>
+              <a:defRPr sz="2400"/>
+            </a:pPr>
+            <a:r>
+              <a:t>   ⚠️  Biggest gap = biggest opportunity!</a:t>
             </a:r>
           </a:p>
         </p:txBody>
@@ -3963,8 +4940,8 @@
 </p:sld>
 </file>
 
-<file path=ppt/slides/slide5.xml><?xml version="1.0" encoding="utf-8"?>
-<p:sld xmlns:a="http://schemas.openxmlformats.org/drawingml/2006/main" xmlns:p="http://schemas.openxmlformats.org/presentationml/2006/main" xmlns:r="http://schemas.openxmlformats.org/officeDocument/2006/relationships">
+<file path=ppt/slides/slide7.xml><?xml version="1.0" encoding="utf-8"?>
+<p:sld xmlns:a="http://schemas.openxmlformats.org/drawingml/2006/main" xmlns:r="http://schemas.openxmlformats.org/officeDocument/2006/relationships" xmlns:p="http://schemas.openxmlformats.org/presentationml/2006/main">
   <p:cSld>
     <p:bg>
       <p:bgPr>
@@ -3980,247 +4957,14 @@
         <p:cNvGrpSpPr/>
         <p:nvPr/>
       </p:nvGrpSpPr>
-      <p:grpSpPr/>
-      <p:sp>
-        <p:nvSpPr>
-          <p:cNvPr id="2" name="TextBox 1"/>
-          <p:cNvSpPr txBox="1"/>
-          <p:nvPr/>
-        </p:nvSpPr>
-        <p:spPr>
-          <a:xfrm>
-            <a:off x="457200" y="274320"/>
-            <a:ext cx="11277295" cy="731520"/>
-          </a:xfrm>
-          <a:prstGeom prst="rect">
-            <a:avLst/>
-          </a:prstGeom>
-          <a:noFill/>
-        </p:spPr>
-        <p:txBody>
-          <a:bodyPr wrap="none">
-            <a:spAutoFit/>
-          </a:bodyPr>
-          <a:lstStyle/>
-          <a:p>
-            <a:pPr>
-              <a:defRPr sz="4000" b="1">
-                <a:solidFill>
-                  <a:srgbClr val="1A2332"/>
-                </a:solidFill>
-              </a:defRPr>
-            </a:pPr>
-            <a:r>
-              <a:t>Four Core Research Themes</a:t>
-            </a:r>
-          </a:p>
-        </p:txBody>
-      </p:sp>
-      <p:sp>
-        <p:nvSpPr>
-          <p:cNvPr id="3" name="TextBox 2"/>
-          <p:cNvSpPr txBox="1"/>
-          <p:nvPr/>
-        </p:nvSpPr>
-        <p:spPr>
-          <a:xfrm>
-            <a:off x="914400" y="1371600"/>
-            <a:ext cx="10362895" cy="5029200"/>
-          </a:xfrm>
-          <a:prstGeom prst="rect">
-            <a:avLst/>
-          </a:prstGeom>
-          <a:noFill/>
-        </p:spPr>
-        <p:txBody>
-          <a:bodyPr wrap="square">
-            <a:spAutoFit/>
-          </a:bodyPr>
-          <a:lstStyle/>
-          <a:p>
-            <a:pPr>
-              <a:spcBef>
-                <a:spcPts val="1200"/>
-              </a:spcBef>
-              <a:defRPr sz="2400"/>
-            </a:pPr>
-            <a:r>
-              <a:t>🔵 42% Data Management for Agentic Systems</a:t>
-            </a:r>
-          </a:p>
-          <a:p>
-            <a:pPr>
-              <a:spcBef>
-                <a:spcPts val="1200"/>
-              </a:spcBef>
-              <a:defRPr sz="2400"/>
-            </a:pPr>
-            <a:r>
-              <a:t>   Building the infrastructure agents need</a:t>
-            </a:r>
-          </a:p>
-          <a:p>
-            <a:pPr>
-              <a:spcBef>
-                <a:spcPts val="1200"/>
-              </a:spcBef>
-              <a:defRPr sz="2400"/>
-            </a:pPr>
-            <a:r>
-              <a:t>   (GitLake, Data Canvas, Structured State Management)</a:t>
-            </a:r>
-          </a:p>
-          <a:p>
-            <a:pPr>
-              <a:spcBef>
-                <a:spcPts val="1200"/>
-              </a:spcBef>
-              <a:defRPr sz="2400"/>
-            </a:pPr>
-          </a:p>
-          <a:p>
-            <a:pPr>
-              <a:spcBef>
-                <a:spcPts val="1200"/>
-              </a:spcBef>
-              <a:defRPr sz="2400"/>
-            </a:pPr>
-            <a:r>
-              <a:t>🟣 25% Agentic Systems for Data Management</a:t>
-            </a:r>
-          </a:p>
-          <a:p>
-            <a:pPr>
-              <a:spcBef>
-                <a:spcPts val="1200"/>
-              </a:spcBef>
-              <a:defRPr sz="2400"/>
-            </a:pPr>
-            <a:r>
-              <a:t>   Agents that help manage and discover data</a:t>
-            </a:r>
-          </a:p>
-          <a:p>
-            <a:pPr>
-              <a:spcBef>
-                <a:spcPts val="1200"/>
-              </a:spcBef>
-              <a:defRPr sz="2400"/>
-            </a:pPr>
-            <a:r>
-              <a:t>   (ASMR, GUIDE, Multi-agent Framework)</a:t>
-            </a:r>
-          </a:p>
-          <a:p>
-            <a:pPr>
-              <a:spcBef>
-                <a:spcPts val="1200"/>
-              </a:spcBef>
-              <a:defRPr sz="2400"/>
-            </a:pPr>
-          </a:p>
-          <a:p>
-            <a:pPr>
-              <a:spcBef>
-                <a:spcPts val="1200"/>
-              </a:spcBef>
-              <a:defRPr sz="2400"/>
-            </a:pPr>
-            <a:r>
-              <a:t>🟢 42% Human-Centered &amp; Human-in-the-Loop</a:t>
-            </a:r>
-          </a:p>
-          <a:p>
-            <a:pPr>
-              <a:spcBef>
-                <a:spcPts val="1200"/>
-              </a:spcBef>
-              <a:defRPr sz="2400"/>
-            </a:pPr>
-            <a:r>
-              <a:t>   Keeping humans in control</a:t>
-            </a:r>
-          </a:p>
-          <a:p>
-            <a:pPr>
-              <a:spcBef>
-                <a:spcPts val="1200"/>
-              </a:spcBef>
-              <a:defRPr sz="2400"/>
-            </a:pPr>
-            <a:r>
-              <a:t>   (Walk Before You Run, AgentTrails, Be Fair!)</a:t>
-            </a:r>
-          </a:p>
-          <a:p>
-            <a:pPr>
-              <a:spcBef>
-                <a:spcPts val="1200"/>
-              </a:spcBef>
-              <a:defRPr sz="2400"/>
-            </a:pPr>
-          </a:p>
-          <a:p>
-            <a:pPr>
-              <a:spcBef>
-                <a:spcPts val="1200"/>
-              </a:spcBef>
-              <a:defRPr sz="2400"/>
-            </a:pPr>
-            <a:r>
-              <a:t>🔴 8% Evaluation, Reliability &amp; Learning</a:t>
-            </a:r>
-          </a:p>
-          <a:p>
-            <a:pPr>
-              <a:spcBef>
-                <a:spcPts val="1200"/>
-              </a:spcBef>
-              <a:defRPr sz="2400"/>
-            </a:pPr>
-            <a:r>
-              <a:t>   How to measure and trust these systems (SANA)</a:t>
-            </a:r>
-          </a:p>
-          <a:p>
-            <a:pPr>
-              <a:spcBef>
-                <a:spcPts val="1200"/>
-              </a:spcBef>
-              <a:defRPr sz="2400"/>
-            </a:pPr>
-            <a:r>
-              <a:t>   ⚠️  Biggest gap = biggest opportunity!</a:t>
-            </a:r>
-          </a:p>
-        </p:txBody>
-      </p:sp>
-    </p:spTree>
-  </p:cSld>
-  <p:clrMapOvr>
-    <a:masterClrMapping/>
-  </p:clrMapOvr>
-</p:sld>
-</file>
-
-<file path=ppt/slides/slide6.xml><?xml version="1.0" encoding="utf-8"?>
-<p:sld xmlns:a="http://schemas.openxmlformats.org/drawingml/2006/main" xmlns:p="http://schemas.openxmlformats.org/presentationml/2006/main" xmlns:r="http://schemas.openxmlformats.org/officeDocument/2006/relationships">
-  <p:cSld>
-    <p:bg>
-      <p:bgPr>
-        <a:solidFill>
-          <a:srgbClr val="FFFFFF"/>
-        </a:solidFill>
-        <a:effectLst/>
-      </p:bgPr>
-    </p:bg>
-    <p:spTree>
-      <p:nvGrpSpPr>
-        <p:cNvPr id="1" name=""/>
-        <p:cNvGrpSpPr/>
-        <p:nvPr/>
-      </p:nvGrpSpPr>
-      <p:grpSpPr/>
+      <p:grpSpPr>
+        <a:xfrm>
+          <a:off x="0" y="0"/>
+          <a:ext cx="0" cy="0"/>
+          <a:chOff x="0" y="0"/>
+          <a:chExt cx="0" cy="0"/>
+        </a:xfrm>
+      </p:grpSpPr>
       <p:sp>
         <p:nvSpPr>
           <p:cNvPr id="2" name="TextBox 1"/>
@@ -4372,6 +5116,7 @@
             <a:pPr>
               <a:defRPr sz="2000"/>
             </a:pPr>
+            <a:endParaRPr/>
           </a:p>
           <a:p>
             <a:pPr>
@@ -4401,6 +5146,7 @@
             <a:pPr>
               <a:defRPr sz="2000"/>
             </a:pPr>
+            <a:endParaRPr/>
           </a:p>
           <a:p>
             <a:pPr>
@@ -4436,8 +5182,8 @@
 </p:sld>
 </file>
 
-<file path=ppt/slides/slide7.xml><?xml version="1.0" encoding="utf-8"?>
-<p:sld xmlns:a="http://schemas.openxmlformats.org/drawingml/2006/main" xmlns:p="http://schemas.openxmlformats.org/presentationml/2006/main" xmlns:r="http://schemas.openxmlformats.org/officeDocument/2006/relationships">
+<file path=ppt/slides/slide8.xml><?xml version="1.0" encoding="utf-8"?>
+<p:sld xmlns:a="http://schemas.openxmlformats.org/drawingml/2006/main" xmlns:r="http://schemas.openxmlformats.org/officeDocument/2006/relationships" xmlns:p="http://schemas.openxmlformats.org/presentationml/2006/main">
   <p:cSld>
     <p:bg>
       <p:bgPr>
@@ -4453,7 +5199,14 @@
         <p:cNvGrpSpPr/>
         <p:nvPr/>
       </p:nvGrpSpPr>
-      <p:grpSpPr/>
+      <p:grpSpPr>
+        <a:xfrm>
+          <a:off x="0" y="0"/>
+          <a:ext cx="0" cy="0"/>
+          <a:chOff x="0" y="0"/>
+          <a:chExt cx="0" cy="0"/>
+        </a:xfrm>
+      </p:grpSpPr>
       <p:sp>
         <p:nvSpPr>
           <p:cNvPr id="2" name="TextBox 1"/>
@@ -4561,6 +5314,7 @@
               </a:spcBef>
               <a:defRPr sz="2400"/>
             </a:pPr>
+            <a:endParaRPr/>
           </a:p>
           <a:p>
             <a:pPr>
@@ -4624,6 +5378,7 @@
               </a:spcBef>
               <a:defRPr sz="2400"/>
             </a:pPr>
+            <a:endParaRPr/>
           </a:p>
           <a:p>
             <a:pPr>
@@ -4668,8 +5423,8 @@
 </p:sld>
 </file>
 
-<file path=ppt/slides/slide8.xml><?xml version="1.0" encoding="utf-8"?>
-<p:sld xmlns:a="http://schemas.openxmlformats.org/drawingml/2006/main" xmlns:p="http://schemas.openxmlformats.org/presentationml/2006/main" xmlns:r="http://schemas.openxmlformats.org/officeDocument/2006/relationships">
+<file path=ppt/slides/slide9.xml><?xml version="1.0" encoding="utf-8"?>
+<p:sld xmlns:a="http://schemas.openxmlformats.org/drawingml/2006/main" xmlns:r="http://schemas.openxmlformats.org/officeDocument/2006/relationships" xmlns:p="http://schemas.openxmlformats.org/presentationml/2006/main">
   <p:cSld>
     <p:bg>
       <p:bgPr>
@@ -4685,7 +5440,14 @@
         <p:cNvGrpSpPr/>
         <p:nvPr/>
       </p:nvGrpSpPr>
-      <p:grpSpPr/>
+      <p:grpSpPr>
+        <a:xfrm>
+          <a:off x="0" y="0"/>
+          <a:ext cx="0" cy="0"/>
+          <a:chOff x="0" y="0"/>
+          <a:chExt cx="0" cy="0"/>
+        </a:xfrm>
+      </p:grpSpPr>
       <p:sp>
         <p:nvSpPr>
           <p:cNvPr id="2" name="TextBox 1"/>
@@ -4760,6 +5522,7 @@
               </a:spcBef>
               <a:defRPr sz="2400"/>
             </a:pPr>
+            <a:endParaRPr/>
           </a:p>
           <a:p>
             <a:pPr>
@@ -4790,6 +5553,7 @@
               </a:spcBef>
               <a:defRPr sz="2400"/>
             </a:pPr>
+            <a:endParaRPr/>
           </a:p>
           <a:p>
             <a:pPr>
@@ -4864,6 +5628,7 @@
               </a:spcBef>
               <a:defRPr sz="2400"/>
             </a:pPr>
+            <a:endParaRPr/>
           </a:p>
           <a:p>
             <a:pPr>
@@ -4885,257 +5650,6 @@
             </a:pPr>
             <a:r>
               <a:t>   Hard questions welcome. No polite consensus.</a:t>
-            </a:r>
-          </a:p>
-        </p:txBody>
-      </p:sp>
-    </p:spTree>
-  </p:cSld>
-  <p:clrMapOvr>
-    <a:masterClrMapping/>
-  </p:clrMapOvr>
-</p:sld>
-</file>
-
-<file path=ppt/slides/slide9.xml><?xml version="1.0" encoding="utf-8"?>
-<p:sld xmlns:a="http://schemas.openxmlformats.org/drawingml/2006/main" xmlns:p="http://schemas.openxmlformats.org/presentationml/2006/main" xmlns:r="http://schemas.openxmlformats.org/officeDocument/2006/relationships">
-  <p:cSld>
-    <p:bg>
-      <p:bgPr>
-        <a:solidFill>
-          <a:srgbClr val="FFFFFF"/>
-        </a:solidFill>
-        <a:effectLst/>
-      </p:bgPr>
-    </p:bg>
-    <p:spTree>
-      <p:nvGrpSpPr>
-        <p:cNvPr id="1" name=""/>
-        <p:cNvGrpSpPr/>
-        <p:nvPr/>
-      </p:nvGrpSpPr>
-      <p:grpSpPr/>
-      <p:sp>
-        <p:nvSpPr>
-          <p:cNvPr id="2" name="TextBox 1"/>
-          <p:cNvSpPr txBox="1"/>
-          <p:nvPr/>
-        </p:nvSpPr>
-        <p:spPr>
-          <a:xfrm>
-            <a:off x="457200" y="274320"/>
-            <a:ext cx="11277295" cy="731520"/>
-          </a:xfrm>
-          <a:prstGeom prst="rect">
-            <a:avLst/>
-          </a:prstGeom>
-          <a:noFill/>
-        </p:spPr>
-        <p:txBody>
-          <a:bodyPr wrap="none">
-            <a:spAutoFit/>
-          </a:bodyPr>
-          <a:lstStyle/>
-          <a:p>
-            <a:pPr>
-              <a:defRPr sz="4000" b="1">
-                <a:solidFill>
-                  <a:srgbClr val="1A2332"/>
-                </a:solidFill>
-              </a:defRPr>
-            </a:pPr>
-            <a:r>
-              <a:t>What Makes DASHSys Different</a:t>
-            </a:r>
-          </a:p>
-        </p:txBody>
-      </p:sp>
-      <p:sp>
-        <p:nvSpPr>
-          <p:cNvPr id="3" name="TextBox 2"/>
-          <p:cNvSpPr txBox="1"/>
-          <p:nvPr/>
-        </p:nvSpPr>
-        <p:spPr>
-          <a:xfrm>
-            <a:off x="914400" y="1371600"/>
-            <a:ext cx="10362895" cy="5029200"/>
-          </a:xfrm>
-          <a:prstGeom prst="rect">
-            <a:avLst/>
-          </a:prstGeom>
-          <a:noFill/>
-        </p:spPr>
-        <p:txBody>
-          <a:bodyPr wrap="square">
-            <a:spAutoFit/>
-          </a:bodyPr>
-          <a:lstStyle/>
-          <a:p>
-            <a:pPr>
-              <a:spcBef>
-                <a:spcPts val="1200"/>
-              </a:spcBef>
-              <a:defRPr sz="2400"/>
-            </a:pPr>
-            <a:r>
-              <a:t>1️⃣  Integration, Not Separation</a:t>
-            </a:r>
-          </a:p>
-          <a:p>
-            <a:pPr>
-              <a:spcBef>
-                <a:spcPts val="1200"/>
-              </a:spcBef>
-              <a:defRPr sz="2400"/>
-            </a:pPr>
-            <a:r>
-              <a:t>    Papers bridge data systems ↔ AI systems</a:t>
-            </a:r>
-          </a:p>
-          <a:p>
-            <a:pPr>
-              <a:spcBef>
-                <a:spcPts val="1200"/>
-              </a:spcBef>
-              <a:defRPr sz="2400"/>
-            </a:pPr>
-            <a:r>
-              <a:t>    Not 'which side wins' but 'how they work together'</a:t>
-            </a:r>
-          </a:p>
-          <a:p>
-            <a:pPr>
-              <a:spcBef>
-                <a:spcPts val="1200"/>
-              </a:spcBef>
-              <a:defRPr sz="2400"/>
-            </a:pPr>
-          </a:p>
-          <a:p>
-            <a:pPr>
-              <a:spcBef>
-                <a:spcPts val="1200"/>
-              </a:spcBef>
-              <a:defRPr sz="2400"/>
-            </a:pPr>
-            <a:r>
-              <a:t>2️⃣  Human-in-the-Loop is Non-Negotiable</a:t>
-            </a:r>
-          </a:p>
-          <a:p>
-            <a:pPr>
-              <a:spcBef>
-                <a:spcPts val="1200"/>
-              </a:spcBef>
-              <a:defRPr sz="2400"/>
-            </a:pPr>
-            <a:r>
-              <a:t>    58% of papers include HITL</a:t>
-            </a:r>
-          </a:p>
-          <a:p>
-            <a:pPr>
-              <a:spcBef>
-                <a:spcPts val="1200"/>
-              </a:spcBef>
-              <a:defRPr sz="2400"/>
-            </a:pPr>
-            <a:r>
-              <a:t>    Not automation vs. oversight</a:t>
-            </a:r>
-          </a:p>
-          <a:p>
-            <a:pPr>
-              <a:spcBef>
-                <a:spcPts val="1200"/>
-              </a:spcBef>
-              <a:defRPr sz="2400"/>
-            </a:pPr>
-            <a:r>
-              <a:t>    But automation WITH oversight</a:t>
-            </a:r>
-          </a:p>
-          <a:p>
-            <a:pPr>
-              <a:spcBef>
-                <a:spcPts val="1200"/>
-              </a:spcBef>
-              <a:defRPr sz="2400"/>
-            </a:pPr>
-          </a:p>
-          <a:p>
-            <a:pPr>
-              <a:spcBef>
-                <a:spcPts val="1200"/>
-              </a:spcBef>
-              <a:defRPr sz="2400"/>
-            </a:pPr>
-            <a:r>
-              <a:t>3️⃣  Production Reality Meets Research Vision</a:t>
-            </a:r>
-          </a:p>
-          <a:p>
-            <a:pPr>
-              <a:spcBef>
-                <a:spcPts val="1200"/>
-              </a:spcBef>
-              <a:defRPr sz="2400"/>
-            </a:pPr>
-            <a:r>
-              <a:t>    Industry speakers + academic depth</a:t>
-            </a:r>
-          </a:p>
-          <a:p>
-            <a:pPr>
-              <a:spcBef>
-                <a:spcPts val="1200"/>
-              </a:spcBef>
-              <a:defRPr sz="2400"/>
-            </a:pPr>
-            <a:r>
-              <a:t>    Systems track tests ideas on real data</a:t>
-            </a:r>
-          </a:p>
-          <a:p>
-            <a:pPr>
-              <a:spcBef>
-                <a:spcPts val="1200"/>
-              </a:spcBef>
-              <a:defRPr sz="2400"/>
-            </a:pPr>
-            <a:r>
-              <a:t>    Gap analysis → research agenda</a:t>
-            </a:r>
-          </a:p>
-          <a:p>
-            <a:pPr>
-              <a:spcBef>
-                <a:spcPts val="1200"/>
-              </a:spcBef>
-              <a:defRPr sz="2400"/>
-            </a:pPr>
-          </a:p>
-          <a:p>
-            <a:pPr>
-              <a:spcBef>
-                <a:spcPts val="1200"/>
-              </a:spcBef>
-              <a:defRPr sz="2400"/>
-            </a:pPr>
-            <a:r>
-              <a:t>🎯 We're not just publishing papers.</a:t>
-            </a:r>
-          </a:p>
-          <a:p>
-            <a:pPr>
-              <a:spcBef>
-                <a:spcPts val="1200"/>
-              </a:spcBef>
-              <a:defRPr sz="2400"/>
-            </a:pPr>
-            <a:r>
-              <a:t>   We're defining how data systems evolve for an agentic era.</a:t>
             </a:r>
           </a:p>
         </p:txBody>

</xml_diff>